<commit_message>
chore: save final project artifacts
</commit_message>
<xml_diff>
--- a/docs/presentation/intermediate-progress-presentation.pptx
+++ b/docs/presentation/intermediate-progress-presentation.pptx
@@ -5,22 +5,22 @@
     <p:sldMasterId id="2147483648" r:id="rId1"/>
   </p:sldMasterIdLst>
   <p:sldIdLst>
-    <p:sldId id="256" r:id="rId7"/>
-    <p:sldId id="257" r:id="rId8"/>
-    <p:sldId id="258" r:id="rId9"/>
-    <p:sldId id="259" r:id="rId10"/>
-    <p:sldId id="260" r:id="rId11"/>
-    <p:sldId id="261" r:id="rId12"/>
-    <p:sldId id="262" r:id="rId13"/>
-    <p:sldId id="263" r:id="rId14"/>
-    <p:sldId id="264" r:id="rId15"/>
-    <p:sldId id="265" r:id="rId16"/>
-    <p:sldId id="266" r:id="rId17"/>
-    <p:sldId id="267" r:id="rId18"/>
-    <p:sldId id="268" r:id="rId19"/>
-    <p:sldId id="269" r:id="rId20"/>
+    <p:sldId id="256" r:id="rId2"/>
+    <p:sldId id="257" r:id="rId3"/>
+    <p:sldId id="258" r:id="rId4"/>
+    <p:sldId id="259" r:id="rId5"/>
+    <p:sldId id="260" r:id="rId6"/>
+    <p:sldId id="261" r:id="rId7"/>
+    <p:sldId id="262" r:id="rId8"/>
+    <p:sldId id="263" r:id="rId9"/>
+    <p:sldId id="264" r:id="rId10"/>
+    <p:sldId id="265" r:id="rId11"/>
+    <p:sldId id="266" r:id="rId12"/>
+    <p:sldId id="267" r:id="rId13"/>
+    <p:sldId id="268" r:id="rId14"/>
+    <p:sldId id="269" r:id="rId15"/>
   </p:sldIdLst>
-  <p:sldSz cx="12191695" cy="6858000" type="screen4x3"/>
+  <p:sldSz cx="12192000" cy="6858000"/>
   <p:notesSz cx="6858000" cy="9144000"/>
   <p:defaultTextStyle>
     <a:defPPr>
@@ -117,6 +117,22 @@
       </a:defRPr>
     </a:lvl9pPr>
   </p:defaultTextStyle>
+  <p:extLst>
+    <p:ext uri="{EFAFB233-063F-42B5-8137-9DF3F51BA10A}">
+      <p15:sldGuideLst xmlns:p15="http://schemas.microsoft.com/office/powerpoint/2012/main">
+        <p15:guide id="1" orient="horz" pos="2160">
+          <p15:clr>
+            <a:srgbClr val="A4A3A4"/>
+          </p15:clr>
+        </p15:guide>
+        <p15:guide id="2" pos="2880">
+          <p15:clr>
+            <a:srgbClr val="A4A3A4"/>
+          </p15:clr>
+        </p15:guide>
+      </p15:sldGuideLst>
+    </p:ext>
+  </p:extLst>
 </p:presentation>
 </file>
 
@@ -158,10 +174,9 @@
           <a:lstStyle/>
           <a:p>
             <a:r>
-              <a:rPr lang="en-US" smtClean="0"/>
+              <a:rPr lang="en-US"/>
               <a:t>Click to edit Master title style</a:t>
             </a:r>
-            <a:endParaRPr lang="en-US"/>
           </a:p>
         </p:txBody>
       </p:sp>
@@ -277,10 +292,9 @@
           </a:lstStyle>
           <a:p>
             <a:r>
-              <a:rPr lang="en-US" smtClean="0"/>
+              <a:rPr lang="en-US"/>
               <a:t>Click to edit Master subtitle style</a:t>
             </a:r>
-            <a:endParaRPr lang="en-US"/>
           </a:p>
         </p:txBody>
       </p:sp>
@@ -301,7 +315,7 @@
           <a:p>
             <a:fld id="{5BCAD085-E8A6-8845-BD4E-CB4CCA059FC4}" type="datetimeFigureOut">
               <a:rPr lang="en-US" smtClean="0"/>
-              <a:t>1/27/13</a:t>
+              <a:t>5/6/26</a:t>
             </a:fld>
             <a:endParaRPr lang="en-US"/>
           </a:p>
@@ -395,10 +409,9 @@
           <a:lstStyle/>
           <a:p>
             <a:r>
-              <a:rPr lang="en-US" smtClean="0"/>
+              <a:rPr lang="en-US"/>
               <a:t>Click to edit Master title style</a:t>
             </a:r>
-            <a:endParaRPr lang="en-US"/>
           </a:p>
         </p:txBody>
       </p:sp>
@@ -419,38 +432,37 @@
           <a:p>
             <a:pPr lvl="0"/>
             <a:r>
-              <a:rPr lang="en-US" smtClean="0"/>
+              <a:rPr lang="en-US"/>
               <a:t>Click to edit Master text styles</a:t>
             </a:r>
           </a:p>
           <a:p>
             <a:pPr lvl="1"/>
             <a:r>
-              <a:rPr lang="en-US" smtClean="0"/>
+              <a:rPr lang="en-US"/>
               <a:t>Second level</a:t>
             </a:r>
           </a:p>
           <a:p>
             <a:pPr lvl="2"/>
             <a:r>
-              <a:rPr lang="en-US" smtClean="0"/>
+              <a:rPr lang="en-US"/>
               <a:t>Third level</a:t>
             </a:r>
           </a:p>
           <a:p>
             <a:pPr lvl="3"/>
             <a:r>
-              <a:rPr lang="en-US" smtClean="0"/>
+              <a:rPr lang="en-US"/>
               <a:t>Fourth level</a:t>
             </a:r>
           </a:p>
           <a:p>
             <a:pPr lvl="4"/>
             <a:r>
-              <a:rPr lang="en-US" smtClean="0"/>
+              <a:rPr lang="en-US"/>
               <a:t>Fifth level</a:t>
             </a:r>
-            <a:endParaRPr lang="en-US"/>
           </a:p>
         </p:txBody>
       </p:sp>
@@ -471,7 +483,7 @@
           <a:p>
             <a:fld id="{5BCAD085-E8A6-8845-BD4E-CB4CCA059FC4}" type="datetimeFigureOut">
               <a:rPr lang="en-US" smtClean="0"/>
-              <a:t>1/27/13</a:t>
+              <a:t>5/6/26</a:t>
             </a:fld>
             <a:endParaRPr lang="en-US"/>
           </a:p>
@@ -570,10 +582,9 @@
           <a:lstStyle/>
           <a:p>
             <a:r>
-              <a:rPr lang="en-US" smtClean="0"/>
+              <a:rPr lang="en-US"/>
               <a:t>Click to edit Master title style</a:t>
             </a:r>
-            <a:endParaRPr lang="en-US"/>
           </a:p>
         </p:txBody>
       </p:sp>
@@ -599,38 +610,37 @@
           <a:p>
             <a:pPr lvl="0"/>
             <a:r>
-              <a:rPr lang="en-US" smtClean="0"/>
+              <a:rPr lang="en-US"/>
               <a:t>Click to edit Master text styles</a:t>
             </a:r>
           </a:p>
           <a:p>
             <a:pPr lvl="1"/>
             <a:r>
-              <a:rPr lang="en-US" smtClean="0"/>
+              <a:rPr lang="en-US"/>
               <a:t>Second level</a:t>
             </a:r>
           </a:p>
           <a:p>
             <a:pPr lvl="2"/>
             <a:r>
-              <a:rPr lang="en-US" smtClean="0"/>
+              <a:rPr lang="en-US"/>
               <a:t>Third level</a:t>
             </a:r>
           </a:p>
           <a:p>
             <a:pPr lvl="3"/>
             <a:r>
-              <a:rPr lang="en-US" smtClean="0"/>
+              <a:rPr lang="en-US"/>
               <a:t>Fourth level</a:t>
             </a:r>
           </a:p>
           <a:p>
             <a:pPr lvl="4"/>
             <a:r>
-              <a:rPr lang="en-US" smtClean="0"/>
+              <a:rPr lang="en-US"/>
               <a:t>Fifth level</a:t>
             </a:r>
-            <a:endParaRPr lang="en-US"/>
           </a:p>
         </p:txBody>
       </p:sp>
@@ -651,7 +661,7 @@
           <a:p>
             <a:fld id="{5BCAD085-E8A6-8845-BD4E-CB4CCA059FC4}" type="datetimeFigureOut">
               <a:rPr lang="en-US" smtClean="0"/>
-              <a:t>1/27/13</a:t>
+              <a:t>5/6/26</a:t>
             </a:fld>
             <a:endParaRPr lang="en-US"/>
           </a:p>
@@ -745,10 +755,9 @@
           <a:lstStyle/>
           <a:p>
             <a:r>
-              <a:rPr lang="en-US" smtClean="0"/>
+              <a:rPr lang="en-US"/>
               <a:t>Click to edit Master title style</a:t>
             </a:r>
-            <a:endParaRPr lang="en-US"/>
           </a:p>
         </p:txBody>
       </p:sp>
@@ -769,38 +778,37 @@
           <a:p>
             <a:pPr lvl="0"/>
             <a:r>
-              <a:rPr lang="en-US" smtClean="0"/>
+              <a:rPr lang="en-US"/>
               <a:t>Click to edit Master text styles</a:t>
             </a:r>
           </a:p>
           <a:p>
             <a:pPr lvl="1"/>
             <a:r>
-              <a:rPr lang="en-US" smtClean="0"/>
+              <a:rPr lang="en-US"/>
               <a:t>Second level</a:t>
             </a:r>
           </a:p>
           <a:p>
             <a:pPr lvl="2"/>
             <a:r>
-              <a:rPr lang="en-US" smtClean="0"/>
+              <a:rPr lang="en-US"/>
               <a:t>Third level</a:t>
             </a:r>
           </a:p>
           <a:p>
             <a:pPr lvl="3"/>
             <a:r>
-              <a:rPr lang="en-US" smtClean="0"/>
+              <a:rPr lang="en-US"/>
               <a:t>Fourth level</a:t>
             </a:r>
           </a:p>
           <a:p>
             <a:pPr lvl="4"/>
             <a:r>
-              <a:rPr lang="en-US" smtClean="0"/>
+              <a:rPr lang="en-US"/>
               <a:t>Fifth level</a:t>
             </a:r>
-            <a:endParaRPr lang="en-US"/>
           </a:p>
         </p:txBody>
       </p:sp>
@@ -821,7 +829,7 @@
           <a:p>
             <a:fld id="{5BCAD085-E8A6-8845-BD4E-CB4CCA059FC4}" type="datetimeFigureOut">
               <a:rPr lang="en-US" smtClean="0"/>
-              <a:t>1/27/13</a:t>
+              <a:t>5/6/26</a:t>
             </a:fld>
             <a:endParaRPr lang="en-US"/>
           </a:p>
@@ -924,10 +932,9 @@
           </a:lstStyle>
           <a:p>
             <a:r>
-              <a:rPr lang="en-US" smtClean="0"/>
+              <a:rPr lang="en-US"/>
               <a:t>Click to edit Master title style</a:t>
             </a:r>
-            <a:endParaRPr lang="en-US"/>
           </a:p>
         </p:txBody>
       </p:sp>
@@ -1044,7 +1051,7 @@
           <a:p>
             <a:pPr lvl="0"/>
             <a:r>
-              <a:rPr lang="en-US" smtClean="0"/>
+              <a:rPr lang="en-US"/>
               <a:t>Click to edit Master text styles</a:t>
             </a:r>
           </a:p>
@@ -1067,7 +1074,7 @@
           <a:p>
             <a:fld id="{5BCAD085-E8A6-8845-BD4E-CB4CCA059FC4}" type="datetimeFigureOut">
               <a:rPr lang="en-US" smtClean="0"/>
-              <a:t>1/27/13</a:t>
+              <a:t>5/6/26</a:t>
             </a:fld>
             <a:endParaRPr lang="en-US"/>
           </a:p>
@@ -1161,10 +1168,9 @@
           <a:lstStyle/>
           <a:p>
             <a:r>
-              <a:rPr lang="en-US" smtClean="0"/>
+              <a:rPr lang="en-US"/>
               <a:t>Click to edit Master title style</a:t>
             </a:r>
-            <a:endParaRPr lang="en-US"/>
           </a:p>
         </p:txBody>
       </p:sp>
@@ -1218,38 +1224,37 @@
           <a:p>
             <a:pPr lvl="0"/>
             <a:r>
-              <a:rPr lang="en-US" smtClean="0"/>
+              <a:rPr lang="en-US"/>
               <a:t>Click to edit Master text styles</a:t>
             </a:r>
           </a:p>
           <a:p>
             <a:pPr lvl="1"/>
             <a:r>
-              <a:rPr lang="en-US" smtClean="0"/>
+              <a:rPr lang="en-US"/>
               <a:t>Second level</a:t>
             </a:r>
           </a:p>
           <a:p>
             <a:pPr lvl="2"/>
             <a:r>
-              <a:rPr lang="en-US" smtClean="0"/>
+              <a:rPr lang="en-US"/>
               <a:t>Third level</a:t>
             </a:r>
           </a:p>
           <a:p>
             <a:pPr lvl="3"/>
             <a:r>
-              <a:rPr lang="en-US" smtClean="0"/>
+              <a:rPr lang="en-US"/>
               <a:t>Fourth level</a:t>
             </a:r>
           </a:p>
           <a:p>
             <a:pPr lvl="4"/>
             <a:r>
-              <a:rPr lang="en-US" smtClean="0"/>
+              <a:rPr lang="en-US"/>
               <a:t>Fifth level</a:t>
             </a:r>
-            <a:endParaRPr lang="en-US"/>
           </a:p>
         </p:txBody>
       </p:sp>
@@ -1303,38 +1308,37 @@
           <a:p>
             <a:pPr lvl="0"/>
             <a:r>
-              <a:rPr lang="en-US" smtClean="0"/>
+              <a:rPr lang="en-US"/>
               <a:t>Click to edit Master text styles</a:t>
             </a:r>
           </a:p>
           <a:p>
             <a:pPr lvl="1"/>
             <a:r>
-              <a:rPr lang="en-US" smtClean="0"/>
+              <a:rPr lang="en-US"/>
               <a:t>Second level</a:t>
             </a:r>
           </a:p>
           <a:p>
             <a:pPr lvl="2"/>
             <a:r>
-              <a:rPr lang="en-US" smtClean="0"/>
+              <a:rPr lang="en-US"/>
               <a:t>Third level</a:t>
             </a:r>
           </a:p>
           <a:p>
             <a:pPr lvl="3"/>
             <a:r>
-              <a:rPr lang="en-US" smtClean="0"/>
+              <a:rPr lang="en-US"/>
               <a:t>Fourth level</a:t>
             </a:r>
           </a:p>
           <a:p>
             <a:pPr lvl="4"/>
             <a:r>
-              <a:rPr lang="en-US" smtClean="0"/>
+              <a:rPr lang="en-US"/>
               <a:t>Fifth level</a:t>
             </a:r>
-            <a:endParaRPr lang="en-US"/>
           </a:p>
         </p:txBody>
       </p:sp>
@@ -1355,7 +1359,7 @@
           <a:p>
             <a:fld id="{5BCAD085-E8A6-8845-BD4E-CB4CCA059FC4}" type="datetimeFigureOut">
               <a:rPr lang="en-US" smtClean="0"/>
-              <a:t>1/27/13</a:t>
+              <a:t>5/6/26</a:t>
             </a:fld>
             <a:endParaRPr lang="en-US"/>
           </a:p>
@@ -1453,10 +1457,9 @@
           </a:lstStyle>
           <a:p>
             <a:r>
-              <a:rPr lang="en-US" smtClean="0"/>
+              <a:rPr lang="en-US"/>
               <a:t>Click to edit Master title style</a:t>
             </a:r>
-            <a:endParaRPr lang="en-US"/>
           </a:p>
         </p:txBody>
       </p:sp>
@@ -1519,7 +1522,7 @@
           <a:p>
             <a:pPr lvl="0"/>
             <a:r>
-              <a:rPr lang="en-US" smtClean="0"/>
+              <a:rPr lang="en-US"/>
               <a:t>Click to edit Master text styles</a:t>
             </a:r>
           </a:p>
@@ -1575,38 +1578,37 @@
           <a:p>
             <a:pPr lvl="0"/>
             <a:r>
-              <a:rPr lang="en-US" smtClean="0"/>
+              <a:rPr lang="en-US"/>
               <a:t>Click to edit Master text styles</a:t>
             </a:r>
           </a:p>
           <a:p>
             <a:pPr lvl="1"/>
             <a:r>
-              <a:rPr lang="en-US" smtClean="0"/>
+              <a:rPr lang="en-US"/>
               <a:t>Second level</a:t>
             </a:r>
           </a:p>
           <a:p>
             <a:pPr lvl="2"/>
             <a:r>
-              <a:rPr lang="en-US" smtClean="0"/>
+              <a:rPr lang="en-US"/>
               <a:t>Third level</a:t>
             </a:r>
           </a:p>
           <a:p>
             <a:pPr lvl="3"/>
             <a:r>
-              <a:rPr lang="en-US" smtClean="0"/>
+              <a:rPr lang="en-US"/>
               <a:t>Fourth level</a:t>
             </a:r>
           </a:p>
           <a:p>
             <a:pPr lvl="4"/>
             <a:r>
-              <a:rPr lang="en-US" smtClean="0"/>
+              <a:rPr lang="en-US"/>
               <a:t>Fifth level</a:t>
             </a:r>
-            <a:endParaRPr lang="en-US"/>
           </a:p>
         </p:txBody>
       </p:sp>
@@ -1669,7 +1671,7 @@
           <a:p>
             <a:pPr lvl="0"/>
             <a:r>
-              <a:rPr lang="en-US" smtClean="0"/>
+              <a:rPr lang="en-US"/>
               <a:t>Click to edit Master text styles</a:t>
             </a:r>
           </a:p>
@@ -1725,38 +1727,37 @@
           <a:p>
             <a:pPr lvl="0"/>
             <a:r>
-              <a:rPr lang="en-US" smtClean="0"/>
+              <a:rPr lang="en-US"/>
               <a:t>Click to edit Master text styles</a:t>
             </a:r>
           </a:p>
           <a:p>
             <a:pPr lvl="1"/>
             <a:r>
-              <a:rPr lang="en-US" smtClean="0"/>
+              <a:rPr lang="en-US"/>
               <a:t>Second level</a:t>
             </a:r>
           </a:p>
           <a:p>
             <a:pPr lvl="2"/>
             <a:r>
-              <a:rPr lang="en-US" smtClean="0"/>
+              <a:rPr lang="en-US"/>
               <a:t>Third level</a:t>
             </a:r>
           </a:p>
           <a:p>
             <a:pPr lvl="3"/>
             <a:r>
-              <a:rPr lang="en-US" smtClean="0"/>
+              <a:rPr lang="en-US"/>
               <a:t>Fourth level</a:t>
             </a:r>
           </a:p>
           <a:p>
             <a:pPr lvl="4"/>
             <a:r>
-              <a:rPr lang="en-US" smtClean="0"/>
+              <a:rPr lang="en-US"/>
               <a:t>Fifth level</a:t>
             </a:r>
-            <a:endParaRPr lang="en-US"/>
           </a:p>
         </p:txBody>
       </p:sp>
@@ -1777,7 +1778,7 @@
           <a:p>
             <a:fld id="{5BCAD085-E8A6-8845-BD4E-CB4CCA059FC4}" type="datetimeFigureOut">
               <a:rPr lang="en-US" smtClean="0"/>
-              <a:t>1/27/13</a:t>
+              <a:t>5/6/26</a:t>
             </a:fld>
             <a:endParaRPr lang="en-US"/>
           </a:p>
@@ -1871,10 +1872,9 @@
           <a:lstStyle/>
           <a:p>
             <a:r>
-              <a:rPr lang="en-US" smtClean="0"/>
+              <a:rPr lang="en-US"/>
               <a:t>Click to edit Master title style</a:t>
             </a:r>
-            <a:endParaRPr lang="en-US"/>
           </a:p>
         </p:txBody>
       </p:sp>
@@ -1895,7 +1895,7 @@
           <a:p>
             <a:fld id="{5BCAD085-E8A6-8845-BD4E-CB4CCA059FC4}" type="datetimeFigureOut">
               <a:rPr lang="en-US" smtClean="0"/>
-              <a:t>1/27/13</a:t>
+              <a:t>5/6/26</a:t>
             </a:fld>
             <a:endParaRPr lang="en-US"/>
           </a:p>
@@ -1990,7 +1990,7 @@
           <a:p>
             <a:fld id="{5BCAD085-E8A6-8845-BD4E-CB4CCA059FC4}" type="datetimeFigureOut">
               <a:rPr lang="en-US" smtClean="0"/>
-              <a:t>1/27/13</a:t>
+              <a:t>5/6/26</a:t>
             </a:fld>
             <a:endParaRPr lang="en-US"/>
           </a:p>
@@ -2093,10 +2093,9 @@
           </a:lstStyle>
           <a:p>
             <a:r>
-              <a:rPr lang="en-US" smtClean="0"/>
+              <a:rPr lang="en-US"/>
               <a:t>Click to edit Master title style</a:t>
             </a:r>
-            <a:endParaRPr lang="en-US"/>
           </a:p>
         </p:txBody>
       </p:sp>
@@ -2150,38 +2149,37 @@
           <a:p>
             <a:pPr lvl="0"/>
             <a:r>
-              <a:rPr lang="en-US" smtClean="0"/>
+              <a:rPr lang="en-US"/>
               <a:t>Click to edit Master text styles</a:t>
             </a:r>
           </a:p>
           <a:p>
             <a:pPr lvl="1"/>
             <a:r>
-              <a:rPr lang="en-US" smtClean="0"/>
+              <a:rPr lang="en-US"/>
               <a:t>Second level</a:t>
             </a:r>
           </a:p>
           <a:p>
             <a:pPr lvl="2"/>
             <a:r>
-              <a:rPr lang="en-US" smtClean="0"/>
+              <a:rPr lang="en-US"/>
               <a:t>Third level</a:t>
             </a:r>
           </a:p>
           <a:p>
             <a:pPr lvl="3"/>
             <a:r>
-              <a:rPr lang="en-US" smtClean="0"/>
+              <a:rPr lang="en-US"/>
               <a:t>Fourth level</a:t>
             </a:r>
           </a:p>
           <a:p>
             <a:pPr lvl="4"/>
             <a:r>
-              <a:rPr lang="en-US" smtClean="0"/>
+              <a:rPr lang="en-US"/>
               <a:t>Fifth level</a:t>
             </a:r>
-            <a:endParaRPr lang="en-US"/>
           </a:p>
         </p:txBody>
       </p:sp>
@@ -2244,7 +2242,7 @@
           <a:p>
             <a:pPr lvl="0"/>
             <a:r>
-              <a:rPr lang="en-US" smtClean="0"/>
+              <a:rPr lang="en-US"/>
               <a:t>Click to edit Master text styles</a:t>
             </a:r>
           </a:p>
@@ -2267,7 +2265,7 @@
           <a:p>
             <a:fld id="{5BCAD085-E8A6-8845-BD4E-CB4CCA059FC4}" type="datetimeFigureOut">
               <a:rPr lang="en-US" smtClean="0"/>
-              <a:t>1/27/13</a:t>
+              <a:t>5/6/26</a:t>
             </a:fld>
             <a:endParaRPr lang="en-US"/>
           </a:p>
@@ -2370,10 +2368,9 @@
           </a:lstStyle>
           <a:p>
             <a:r>
-              <a:rPr lang="en-US" smtClean="0"/>
+              <a:rPr lang="en-US"/>
               <a:t>Click to edit Master title style</a:t>
             </a:r>
-            <a:endParaRPr lang="en-US"/>
           </a:p>
         </p:txBody>
       </p:sp>
@@ -2497,7 +2494,7 @@
           <a:p>
             <a:pPr lvl="0"/>
             <a:r>
-              <a:rPr lang="en-US" smtClean="0"/>
+              <a:rPr lang="en-US"/>
               <a:t>Click to edit Master text styles</a:t>
             </a:r>
           </a:p>
@@ -2520,7 +2517,7 @@
           <a:p>
             <a:fld id="{5BCAD085-E8A6-8845-BD4E-CB4CCA059FC4}" type="datetimeFigureOut">
               <a:rPr lang="en-US" smtClean="0"/>
-              <a:t>1/27/13</a:t>
+              <a:t>5/6/26</a:t>
             </a:fld>
             <a:endParaRPr lang="en-US"/>
           </a:p>
@@ -2629,10 +2626,9 @@
           <a:lstStyle/>
           <a:p>
             <a:r>
-              <a:rPr lang="en-US" smtClean="0"/>
+              <a:rPr lang="en-US"/>
               <a:t>Click to edit Master title style</a:t>
             </a:r>
-            <a:endParaRPr lang="en-US"/>
           </a:p>
         </p:txBody>
       </p:sp>
@@ -2663,38 +2659,37 @@
           <a:p>
             <a:pPr lvl="0"/>
             <a:r>
-              <a:rPr lang="en-US" smtClean="0"/>
+              <a:rPr lang="en-US"/>
               <a:t>Click to edit Master text styles</a:t>
             </a:r>
           </a:p>
           <a:p>
             <a:pPr lvl="1"/>
             <a:r>
-              <a:rPr lang="en-US" smtClean="0"/>
+              <a:rPr lang="en-US"/>
               <a:t>Second level</a:t>
             </a:r>
           </a:p>
           <a:p>
             <a:pPr lvl="2"/>
             <a:r>
-              <a:rPr lang="en-US" smtClean="0"/>
+              <a:rPr lang="en-US"/>
               <a:t>Third level</a:t>
             </a:r>
           </a:p>
           <a:p>
             <a:pPr lvl="3"/>
             <a:r>
-              <a:rPr lang="en-US" smtClean="0"/>
+              <a:rPr lang="en-US"/>
               <a:t>Fourth level</a:t>
             </a:r>
           </a:p>
           <a:p>
             <a:pPr lvl="4"/>
             <a:r>
-              <a:rPr lang="en-US" smtClean="0"/>
+              <a:rPr lang="en-US"/>
               <a:t>Fifth level</a:t>
             </a:r>
-            <a:endParaRPr lang="en-US"/>
           </a:p>
         </p:txBody>
       </p:sp>
@@ -2733,7 +2728,7 @@
           <a:p>
             <a:fld id="{5BCAD085-E8A6-8845-BD4E-CB4CCA059FC4}" type="datetimeFigureOut">
               <a:rPr lang="en-US" smtClean="0"/>
-              <a:t>1/27/13</a:t>
+              <a:t>5/6/26</a:t>
             </a:fld>
             <a:endParaRPr lang="en-US"/>
           </a:p>
@@ -3092,7 +3087,7 @@
 </file>
 
 <file path=ppt/slides/slide1.xml><?xml version="1.0" encoding="utf-8"?>
-<p:sld xmlns:a="http://schemas.openxmlformats.org/drawingml/2006/main" xmlns:p="http://schemas.openxmlformats.org/presentationml/2006/main" xmlns:r="http://schemas.openxmlformats.org/officeDocument/2006/relationships">
+<p:sld xmlns:a="http://schemas.openxmlformats.org/drawingml/2006/main" xmlns:r="http://schemas.openxmlformats.org/officeDocument/2006/relationships" xmlns:p="http://schemas.openxmlformats.org/presentationml/2006/main">
   <p:cSld>
     <p:spTree>
       <p:nvGrpSpPr>
@@ -3100,7 +3095,14 @@
         <p:cNvGrpSpPr/>
         <p:nvPr/>
       </p:nvGrpSpPr>
-      <p:grpSpPr/>
+      <p:grpSpPr>
+        <a:xfrm>
+          <a:off x="0" y="0"/>
+          <a:ext cx="0" cy="0"/>
+          <a:chOff x="0" y="0"/>
+          <a:chExt cx="0" cy="0"/>
+        </a:xfrm>
+      </p:grpSpPr>
       <p:sp>
         <p:nvSpPr>
           <p:cNvPr id="2" name="Rectangle 1"/>
@@ -3141,6 +3143,7 @@
           <a:lstStyle/>
           <a:p>
             <a:pPr algn="ctr"/>
+            <a:endParaRPr sz="2000"/>
           </a:p>
         </p:txBody>
       </p:sp>
@@ -3152,8 +3155,8 @@
         </p:nvSpPr>
         <p:spPr>
           <a:xfrm>
-            <a:off x="457200" y="502920"/>
-            <a:ext cx="11277295" cy="914400"/>
+            <a:off x="457200" y="225028"/>
+            <a:ext cx="3879267" cy="1015663"/>
           </a:xfrm>
           <a:prstGeom prst="rect">
             <a:avLst/>
@@ -3161,14 +3164,14 @@
           <a:noFill/>
         </p:spPr>
         <p:txBody>
-          <a:bodyPr wrap="none" lIns="0" rIns="0" tIns="0" bIns="0">
+          <a:bodyPr wrap="none" lIns="0" tIns="0" rIns="0" bIns="0">
             <a:spAutoFit/>
           </a:bodyPr>
           <a:lstStyle/>
           <a:p>
             <a:pPr algn="l"/>
             <a:r>
-              <a:rPr sz="6000">
+              <a:rPr sz="6600" dirty="0" err="1">
                 <a:solidFill>
                   <a:srgbClr val="FFFFFF"/>
                 </a:solidFill>
@@ -3176,6 +3179,12 @@
               </a:rPr>
               <a:t>CineEmbed</a:t>
             </a:r>
+            <a:endParaRPr sz="6600" dirty="0">
+              <a:solidFill>
+                <a:srgbClr val="FFFFFF"/>
+              </a:solidFill>
+              <a:latin typeface="Calibri Light"/>
+            </a:endParaRPr>
           </a:p>
         </p:txBody>
       </p:sp>
@@ -3188,7 +3197,7 @@
         <p:spPr>
           <a:xfrm>
             <a:off x="457200" y="1280160"/>
-            <a:ext cx="11277295" cy="457200"/>
+            <a:ext cx="6951903" cy="461665"/>
           </a:xfrm>
           <a:prstGeom prst="rect">
             <a:avLst/>
@@ -3202,7 +3211,7 @@
           <a:lstStyle/>
           <a:p>
             <a:r>
-              <a:rPr sz="2000">
+              <a:rPr sz="2400">
                 <a:solidFill>
                   <a:srgbClr val="FFFFFF"/>
                 </a:solidFill>
@@ -3222,7 +3231,7 @@
         <p:spPr>
           <a:xfrm>
             <a:off x="457200" y="2377440"/>
-            <a:ext cx="11277295" cy="457200"/>
+            <a:ext cx="4557786" cy="461665"/>
           </a:xfrm>
           <a:prstGeom prst="rect">
             <a:avLst/>
@@ -3236,7 +3245,7 @@
           <a:lstStyle/>
           <a:p>
             <a:r>
-              <a:rPr sz="2000">
+              <a:rPr sz="2400" dirty="0">
                 <a:solidFill>
                   <a:srgbClr val="2563EB"/>
                 </a:solidFill>
@@ -3255,8 +3264,8 @@
         </p:nvSpPr>
         <p:spPr>
           <a:xfrm>
-            <a:off x="457200" y="3840480"/>
-            <a:ext cx="11277295" cy="548640"/>
+            <a:off x="457200" y="3399888"/>
+            <a:ext cx="11020389" cy="646331"/>
           </a:xfrm>
           <a:prstGeom prst="rect">
             <a:avLst/>
@@ -3270,13 +3279,31 @@
           <a:lstStyle/>
           <a:p>
             <a:r>
-              <a:rPr sz="2200">
+              <a:rPr sz="3600" dirty="0">
                 <a:solidFill>
                   <a:srgbClr val="1E293B"/>
                 </a:solidFill>
                 <a:latin typeface="Calibri"/>
               </a:rPr>
-              <a:t>Ahmet Baran Dincoguz   ·   Arda Arvas   ·   Bertan Kaan Kaya</a:t>
+              <a:t>Ahmet Baran Dincoguz   ·   Arda </a:t>
+            </a:r>
+            <a:r>
+              <a:rPr sz="3600" dirty="0" err="1">
+                <a:solidFill>
+                  <a:srgbClr val="1E293B"/>
+                </a:solidFill>
+                <a:latin typeface="Calibri"/>
+              </a:rPr>
+              <a:t>Arvas</a:t>
+            </a:r>
+            <a:r>
+              <a:rPr sz="3600" dirty="0">
+                <a:solidFill>
+                  <a:srgbClr val="1E293B"/>
+                </a:solidFill>
+                <a:latin typeface="Calibri"/>
+              </a:rPr>
+              <a:t>   ·   Bertan Kaan Kaya</a:t>
             </a:r>
           </a:p>
         </p:txBody>
@@ -3290,7 +3317,7 @@
         <p:spPr>
           <a:xfrm>
             <a:off x="457200" y="4526280"/>
-            <a:ext cx="11277295" cy="457200"/>
+            <a:ext cx="6813275" cy="369332"/>
           </a:xfrm>
           <a:prstGeom prst="rect">
             <a:avLst/>
@@ -3304,7 +3331,7 @@
           <a:lstStyle/>
           <a:p>
             <a:r>
-              <a:rPr sz="1600">
+              <a:rPr dirty="0">
                 <a:solidFill>
                   <a:srgbClr val="64748B"/>
                 </a:solidFill>
@@ -3324,7 +3351,7 @@
         <p:spPr>
           <a:xfrm>
             <a:off x="457200" y="6263640"/>
-            <a:ext cx="11277295" cy="365760"/>
+            <a:ext cx="3512821" cy="338554"/>
           </a:xfrm>
           <a:prstGeom prst="rect">
             <a:avLst/>
@@ -3338,7 +3365,7 @@
           <a:lstStyle/>
           <a:p>
             <a:r>
-              <a:rPr sz="1400">
+              <a:rPr sz="1600">
                 <a:solidFill>
                   <a:srgbClr val="2563EB"/>
                 </a:solidFill>
@@ -3358,7 +3385,7 @@
 </file>
 
 <file path=ppt/slides/slide10.xml><?xml version="1.0" encoding="utf-8"?>
-<p:sld xmlns:a="http://schemas.openxmlformats.org/drawingml/2006/main" xmlns:p="http://schemas.openxmlformats.org/presentationml/2006/main" xmlns:r="http://schemas.openxmlformats.org/officeDocument/2006/relationships">
+<p:sld xmlns:a="http://schemas.openxmlformats.org/drawingml/2006/main" xmlns:r="http://schemas.openxmlformats.org/officeDocument/2006/relationships" xmlns:p="http://schemas.openxmlformats.org/presentationml/2006/main">
   <p:cSld>
     <p:spTree>
       <p:nvGrpSpPr>
@@ -3366,7 +3393,14 @@
         <p:cNvGrpSpPr/>
         <p:nvPr/>
       </p:nvGrpSpPr>
-      <p:grpSpPr/>
+      <p:grpSpPr>
+        <a:xfrm>
+          <a:off x="0" y="0"/>
+          <a:ext cx="0" cy="0"/>
+          <a:chOff x="0" y="0"/>
+          <a:chExt cx="0" cy="0"/>
+        </a:xfrm>
+      </p:grpSpPr>
       <p:sp>
         <p:nvSpPr>
           <p:cNvPr id="2" name="Rectangle 1"/>
@@ -3407,6 +3441,7 @@
           <a:lstStyle/>
           <a:p>
             <a:pPr algn="ctr"/>
+            <a:endParaRPr/>
           </a:p>
         </p:txBody>
       </p:sp>
@@ -3427,7 +3462,7 @@
           <a:noFill/>
         </p:spPr>
         <p:txBody>
-          <a:bodyPr wrap="none" lIns="0" rIns="0" tIns="0" bIns="0">
+          <a:bodyPr wrap="none" lIns="0" tIns="0" rIns="0" bIns="0">
             <a:spAutoFit/>
           </a:bodyPr>
           <a:lstStyle/>
@@ -3462,7 +3497,7 @@
           <a:noFill/>
         </p:spPr>
         <p:txBody>
-          <a:bodyPr wrap="none" lIns="0" rIns="0" tIns="0" bIns="0">
+          <a:bodyPr wrap="none" lIns="0" tIns="0" rIns="0" bIns="0">
             <a:spAutoFit/>
           </a:bodyPr>
           <a:lstStyle/>
@@ -3523,8 +3558,8 @@
         </p:nvSpPr>
         <p:spPr>
           <a:xfrm>
-            <a:off x="457200" y="1737360"/>
-            <a:ext cx="11277295" cy="2377440"/>
+            <a:off x="2982014" y="1374986"/>
+            <a:ext cx="6227666" cy="2769989"/>
           </a:xfrm>
           <a:prstGeom prst="rect">
             <a:avLst/>
@@ -3532,20 +3567,38 @@
           <a:noFill/>
         </p:spPr>
         <p:txBody>
-          <a:bodyPr wrap="none" lIns="0" rIns="0" tIns="0" bIns="0" anchor="ctr">
+          <a:bodyPr wrap="none" lIns="0" tIns="0" rIns="0" bIns="0" anchor="ctr">
             <a:spAutoFit/>
           </a:bodyPr>
           <a:lstStyle/>
           <a:p>
             <a:pPr algn="ctr"/>
             <a:r>
-              <a:rPr sz="18000" b="0">
+              <a:rPr sz="18000" b="0" dirty="0">
                 <a:solidFill>
                   <a:srgbClr val="C2410C"/>
                 </a:solidFill>
                 <a:latin typeface="Calibri Light"/>
               </a:rPr>
-              <a:t>+205 %</a:t>
+              <a:t>+</a:t>
+            </a:r>
+            <a:r>
+              <a:rPr sz="15000" b="0" dirty="0">
+                <a:solidFill>
+                  <a:srgbClr val="C2410C"/>
+                </a:solidFill>
+                <a:latin typeface="Calibri Light"/>
+              </a:rPr>
+              <a:t>205</a:t>
+            </a:r>
+            <a:r>
+              <a:rPr sz="18000" b="0" dirty="0">
+                <a:solidFill>
+                  <a:srgbClr val="C2410C"/>
+                </a:solidFill>
+                <a:latin typeface="Calibri Light"/>
+              </a:rPr>
+              <a:t> %</a:t>
             </a:r>
           </a:p>
         </p:txBody>
@@ -3567,7 +3620,7 @@
           <a:noFill/>
         </p:spPr>
         <p:txBody>
-          <a:bodyPr wrap="square" lIns="0" rIns="0" tIns="0" bIns="0">
+          <a:bodyPr wrap="square" lIns="0" tIns="0" rIns="0" bIns="0">
             <a:spAutoFit/>
           </a:bodyPr>
           <a:lstStyle/>
@@ -3804,7 +3857,7 @@
 </file>
 
 <file path=ppt/slides/slide11.xml><?xml version="1.0" encoding="utf-8"?>
-<p:sld xmlns:a="http://schemas.openxmlformats.org/drawingml/2006/main" xmlns:p="http://schemas.openxmlformats.org/presentationml/2006/main" xmlns:r="http://schemas.openxmlformats.org/officeDocument/2006/relationships">
+<p:sld xmlns:a="http://schemas.openxmlformats.org/drawingml/2006/main" xmlns:r="http://schemas.openxmlformats.org/officeDocument/2006/relationships" xmlns:p="http://schemas.openxmlformats.org/presentationml/2006/main">
   <p:cSld>
     <p:spTree>
       <p:nvGrpSpPr>
@@ -3812,7 +3865,14 @@
         <p:cNvGrpSpPr/>
         <p:nvPr/>
       </p:nvGrpSpPr>
-      <p:grpSpPr/>
+      <p:grpSpPr>
+        <a:xfrm>
+          <a:off x="0" y="0"/>
+          <a:ext cx="0" cy="0"/>
+          <a:chOff x="0" y="0"/>
+          <a:chExt cx="0" cy="0"/>
+        </a:xfrm>
+      </p:grpSpPr>
       <p:sp>
         <p:nvSpPr>
           <p:cNvPr id="2" name="Rectangle 1"/>
@@ -3853,6 +3913,7 @@
           <a:lstStyle/>
           <a:p>
             <a:pPr algn="ctr"/>
+            <a:endParaRPr/>
           </a:p>
         </p:txBody>
       </p:sp>
@@ -3873,7 +3934,7 @@
           <a:noFill/>
         </p:spPr>
         <p:txBody>
-          <a:bodyPr wrap="none" lIns="0" rIns="0" tIns="0" bIns="0">
+          <a:bodyPr wrap="none" lIns="0" tIns="0" rIns="0" bIns="0">
             <a:spAutoFit/>
           </a:bodyPr>
           <a:lstStyle/>
@@ -3908,7 +3969,7 @@
           <a:noFill/>
         </p:spPr>
         <p:txBody>
-          <a:bodyPr wrap="none" lIns="0" rIns="0" tIns="0" bIns="0">
+          <a:bodyPr wrap="none" lIns="0" tIns="0" rIns="0" bIns="0">
             <a:spAutoFit/>
           </a:bodyPr>
           <a:lstStyle/>
@@ -3977,8 +4038,8 @@
         </p:blipFill>
         <p:spPr>
           <a:xfrm>
-            <a:off x="365760" y="1554480"/>
-            <a:ext cx="11430000" cy="2987768"/>
+            <a:off x="294002" y="1600200"/>
+            <a:ext cx="11897693" cy="3110022"/>
           </a:xfrm>
           <a:prstGeom prst="rect">
             <a:avLst/>
@@ -4029,7 +4090,7 @@
 </file>
 
 <file path=ppt/slides/slide12.xml><?xml version="1.0" encoding="utf-8"?>
-<p:sld xmlns:a="http://schemas.openxmlformats.org/drawingml/2006/main" xmlns:p="http://schemas.openxmlformats.org/presentationml/2006/main" xmlns:r="http://schemas.openxmlformats.org/officeDocument/2006/relationships">
+<p:sld xmlns:a="http://schemas.openxmlformats.org/drawingml/2006/main" xmlns:r="http://schemas.openxmlformats.org/officeDocument/2006/relationships" xmlns:p="http://schemas.openxmlformats.org/presentationml/2006/main">
   <p:cSld>
     <p:spTree>
       <p:nvGrpSpPr>
@@ -4037,7 +4098,14 @@
         <p:cNvGrpSpPr/>
         <p:nvPr/>
       </p:nvGrpSpPr>
-      <p:grpSpPr/>
+      <p:grpSpPr>
+        <a:xfrm>
+          <a:off x="0" y="0"/>
+          <a:ext cx="0" cy="0"/>
+          <a:chOff x="0" y="0"/>
+          <a:chExt cx="0" cy="0"/>
+        </a:xfrm>
+      </p:grpSpPr>
       <p:sp>
         <p:nvSpPr>
           <p:cNvPr id="2" name="Rectangle 1"/>
@@ -4078,6 +4146,7 @@
           <a:lstStyle/>
           <a:p>
             <a:pPr algn="ctr"/>
+            <a:endParaRPr/>
           </a:p>
         </p:txBody>
       </p:sp>
@@ -4098,7 +4167,7 @@
           <a:noFill/>
         </p:spPr>
         <p:txBody>
-          <a:bodyPr wrap="none" lIns="0" rIns="0" tIns="0" bIns="0">
+          <a:bodyPr wrap="none" lIns="0" tIns="0" rIns="0" bIns="0">
             <a:spAutoFit/>
           </a:bodyPr>
           <a:lstStyle/>
@@ -4133,7 +4202,7 @@
           <a:noFill/>
         </p:spPr>
         <p:txBody>
-          <a:bodyPr wrap="none" lIns="0" rIns="0" tIns="0" bIns="0">
+          <a:bodyPr wrap="none" lIns="0" tIns="0" rIns="0" bIns="0">
             <a:spAutoFit/>
           </a:bodyPr>
           <a:lstStyle/>
@@ -4202,8 +4271,8 @@
         </p:blipFill>
         <p:spPr>
           <a:xfrm>
-            <a:off x="457200" y="1554480"/>
-            <a:ext cx="6858000" cy="5306938"/>
+            <a:off x="102704" y="1280160"/>
+            <a:ext cx="7212496" cy="5581258"/>
           </a:xfrm>
           <a:prstGeom prst="rect">
             <a:avLst/>
@@ -4227,7 +4296,7 @@
           <a:noFill/>
         </p:spPr>
         <p:txBody>
-          <a:bodyPr wrap="square" lIns="0" rIns="0" tIns="0" bIns="0">
+          <a:bodyPr wrap="square" lIns="0" tIns="0" rIns="0" bIns="0">
             <a:spAutoFit/>
           </a:bodyPr>
           <a:lstStyle/>
@@ -4238,13 +4307,31 @@
               </a:spcAft>
             </a:pPr>
             <a:r>
-              <a:rPr sz="1500">
+              <a:rPr sz="1500" dirty="0">
                 <a:solidFill>
                   <a:srgbClr val="1E293B"/>
                 </a:solidFill>
                 <a:latin typeface="Calibri"/>
               </a:rPr>
-              <a:t>•  ~7.4 % of films have no release date (decade_bin = 0).</a:t>
+              <a:t>•  ~7.4 % of films have no release date (</a:t>
+            </a:r>
+            <a:r>
+              <a:rPr sz="1500" dirty="0" err="1">
+                <a:solidFill>
+                  <a:srgbClr val="1E293B"/>
+                </a:solidFill>
+                <a:latin typeface="Calibri"/>
+              </a:rPr>
+              <a:t>decade_bin</a:t>
+            </a:r>
+            <a:r>
+              <a:rPr sz="1500" dirty="0">
+                <a:solidFill>
+                  <a:srgbClr val="1E293B"/>
+                </a:solidFill>
+                <a:latin typeface="Calibri"/>
+              </a:rPr>
+              <a:t> = 0).</a:t>
             </a:r>
           </a:p>
           <a:p>
@@ -4254,7 +4341,7 @@
               </a:spcAft>
             </a:pPr>
             <a:r>
-              <a:rPr sz="1500">
+              <a:rPr sz="1500" dirty="0">
                 <a:solidFill>
                   <a:srgbClr val="1E293B"/>
                 </a:solidFill>
@@ -4270,7 +4357,7 @@
               </a:spcAft>
             </a:pPr>
             <a:r>
-              <a:rPr sz="1500">
+              <a:rPr sz="1500" dirty="0">
                 <a:solidFill>
                   <a:srgbClr val="1E293B"/>
                 </a:solidFill>
@@ -4286,7 +4373,7 @@
               </a:spcAft>
             </a:pPr>
             <a:r>
-              <a:rPr sz="1500">
+              <a:rPr sz="1500" dirty="0">
                 <a:solidFill>
                   <a:srgbClr val="1E293B"/>
                 </a:solidFill>
@@ -4302,7 +4389,7 @@
               </a:spcAft>
             </a:pPr>
             <a:r>
-              <a:rPr sz="1500">
+              <a:rPr sz="1500" dirty="0">
                 <a:solidFill>
                   <a:srgbClr val="1E293B"/>
                 </a:solidFill>
@@ -4322,7 +4409,7 @@
 </file>
 
 <file path=ppt/slides/slide13.xml><?xml version="1.0" encoding="utf-8"?>
-<p:sld xmlns:a="http://schemas.openxmlformats.org/drawingml/2006/main" xmlns:p="http://schemas.openxmlformats.org/presentationml/2006/main" xmlns:r="http://schemas.openxmlformats.org/officeDocument/2006/relationships">
+<p:sld xmlns:a="http://schemas.openxmlformats.org/drawingml/2006/main" xmlns:r="http://schemas.openxmlformats.org/officeDocument/2006/relationships" xmlns:p="http://schemas.openxmlformats.org/presentationml/2006/main">
   <p:cSld>
     <p:spTree>
       <p:nvGrpSpPr>
@@ -4330,7 +4417,14 @@
         <p:cNvGrpSpPr/>
         <p:nvPr/>
       </p:nvGrpSpPr>
-      <p:grpSpPr/>
+      <p:grpSpPr>
+        <a:xfrm>
+          <a:off x="0" y="0"/>
+          <a:ext cx="0" cy="0"/>
+          <a:chOff x="0" y="0"/>
+          <a:chExt cx="0" cy="0"/>
+        </a:xfrm>
+      </p:grpSpPr>
       <p:sp>
         <p:nvSpPr>
           <p:cNvPr id="2" name="Rectangle 1"/>
@@ -4371,6 +4465,7 @@
           <a:lstStyle/>
           <a:p>
             <a:pPr algn="ctr"/>
+            <a:endParaRPr/>
           </a:p>
         </p:txBody>
       </p:sp>
@@ -4391,7 +4486,7 @@
           <a:noFill/>
         </p:spPr>
         <p:txBody>
-          <a:bodyPr wrap="none" lIns="0" rIns="0" tIns="0" bIns="0">
+          <a:bodyPr wrap="none" lIns="0" tIns="0" rIns="0" bIns="0">
             <a:spAutoFit/>
           </a:bodyPr>
           <a:lstStyle/>
@@ -4426,7 +4521,7 @@
           <a:noFill/>
         </p:spPr>
         <p:txBody>
-          <a:bodyPr wrap="none" lIns="0" rIns="0" tIns="0" bIns="0">
+          <a:bodyPr wrap="none" lIns="0" tIns="0" rIns="0" bIns="0">
             <a:spAutoFit/>
           </a:bodyPr>
           <a:lstStyle/>
@@ -4498,9 +4593,27 @@
                 <a:tableStyleId>{5C22544A-7EE6-4342-B048-85BDC9FD1C3A}</a:tableStyleId>
               </a:tblPr>
               <a:tblGrid>
-                <a:gridCol w="3759098"/>
-                <a:gridCol w="3759098"/>
-                <a:gridCol w="3759099"/>
+                <a:gridCol w="3759098">
+                  <a:extLst>
+                    <a:ext uri="{9D8B030D-6E8A-4147-A177-3AD203B41FA5}">
+                      <a16:colId xmlns:a16="http://schemas.microsoft.com/office/drawing/2014/main" val="20000"/>
+                    </a:ext>
+                  </a:extLst>
+                </a:gridCol>
+                <a:gridCol w="3759098">
+                  <a:extLst>
+                    <a:ext uri="{9D8B030D-6E8A-4147-A177-3AD203B41FA5}">
+                      <a16:colId xmlns:a16="http://schemas.microsoft.com/office/drawing/2014/main" val="20001"/>
+                    </a:ext>
+                  </a:extLst>
+                </a:gridCol>
+                <a:gridCol w="3759099">
+                  <a:extLst>
+                    <a:ext uri="{9D8B030D-6E8A-4147-A177-3AD203B41FA5}">
+                      <a16:colId xmlns:a16="http://schemas.microsoft.com/office/drawing/2014/main" val="20002"/>
+                    </a:ext>
+                  </a:extLst>
+                </a:gridCol>
               </a:tblGrid>
               <a:tr h="457200">
                 <a:tc>
@@ -4572,6 +4685,11 @@
                     </a:solidFill>
                   </a:tcPr>
                 </a:tc>
+                <a:extLst>
+                  <a:ext uri="{0D108BD9-81ED-4DB2-BD59-A6C34878D82A}">
+                    <a16:rowId xmlns:a16="http://schemas.microsoft.com/office/drawing/2014/main" val="10000"/>
+                  </a:ext>
+                </a:extLst>
               </a:tr>
               <a:tr h="457200">
                 <a:tc>
@@ -4643,6 +4761,11 @@
                     </a:solidFill>
                   </a:tcPr>
                 </a:tc>
+                <a:extLst>
+                  <a:ext uri="{0D108BD9-81ED-4DB2-BD59-A6C34878D82A}">
+                    <a16:rowId xmlns:a16="http://schemas.microsoft.com/office/drawing/2014/main" val="10001"/>
+                  </a:ext>
+                </a:extLst>
               </a:tr>
               <a:tr h="457200">
                 <a:tc>
@@ -4714,6 +4837,11 @@
                     </a:solidFill>
                   </a:tcPr>
                 </a:tc>
+                <a:extLst>
+                  <a:ext uri="{0D108BD9-81ED-4DB2-BD59-A6C34878D82A}">
+                    <a16:rowId xmlns:a16="http://schemas.microsoft.com/office/drawing/2014/main" val="10002"/>
+                  </a:ext>
+                </a:extLst>
               </a:tr>
               <a:tr h="457200">
                 <a:tc>
@@ -4785,6 +4913,11 @@
                     </a:solidFill>
                   </a:tcPr>
                 </a:tc>
+                <a:extLst>
+                  <a:ext uri="{0D108BD9-81ED-4DB2-BD59-A6C34878D82A}">
+                    <a16:rowId xmlns:a16="http://schemas.microsoft.com/office/drawing/2014/main" val="10003"/>
+                  </a:ext>
+                </a:extLst>
               </a:tr>
               <a:tr h="457200">
                 <a:tc>
@@ -4856,6 +4989,11 @@
                     </a:solidFill>
                   </a:tcPr>
                 </a:tc>
+                <a:extLst>
+                  <a:ext uri="{0D108BD9-81ED-4DB2-BD59-A6C34878D82A}">
+                    <a16:rowId xmlns:a16="http://schemas.microsoft.com/office/drawing/2014/main" val="10004"/>
+                  </a:ext>
+                </a:extLst>
               </a:tr>
               <a:tr h="457200">
                 <a:tc>
@@ -4927,6 +5065,11 @@
                     </a:solidFill>
                   </a:tcPr>
                 </a:tc>
+                <a:extLst>
+                  <a:ext uri="{0D108BD9-81ED-4DB2-BD59-A6C34878D82A}">
+                    <a16:rowId xmlns:a16="http://schemas.microsoft.com/office/drawing/2014/main" val="10005"/>
+                  </a:ext>
+                </a:extLst>
               </a:tr>
               <a:tr h="457200">
                 <a:tc>
@@ -4998,6 +5141,11 @@
                     </a:solidFill>
                   </a:tcPr>
                 </a:tc>
+                <a:extLst>
+                  <a:ext uri="{0D108BD9-81ED-4DB2-BD59-A6C34878D82A}">
+                    <a16:rowId xmlns:a16="http://schemas.microsoft.com/office/drawing/2014/main" val="10006"/>
+                  </a:ext>
+                </a:extLst>
               </a:tr>
               <a:tr h="457200">
                 <a:tc>
@@ -5069,6 +5217,11 @@
                     </a:solidFill>
                   </a:tcPr>
                 </a:tc>
+                <a:extLst>
+                  <a:ext uri="{0D108BD9-81ED-4DB2-BD59-A6C34878D82A}">
+                    <a16:rowId xmlns:a16="http://schemas.microsoft.com/office/drawing/2014/main" val="10007"/>
+                  </a:ext>
+                </a:extLst>
               </a:tr>
               <a:tr h="457200">
                 <a:tc>
@@ -5140,6 +5293,11 @@
                     </a:solidFill>
                   </a:tcPr>
                 </a:tc>
+                <a:extLst>
+                  <a:ext uri="{0D108BD9-81ED-4DB2-BD59-A6C34878D82A}">
+                    <a16:rowId xmlns:a16="http://schemas.microsoft.com/office/drawing/2014/main" val="10008"/>
+                  </a:ext>
+                </a:extLst>
               </a:tr>
               <a:tr h="457200">
                 <a:tc>
@@ -5211,6 +5369,11 @@
                     </a:solidFill>
                   </a:tcPr>
                 </a:tc>
+                <a:extLst>
+                  <a:ext uri="{0D108BD9-81ED-4DB2-BD59-A6C34878D82A}">
+                    <a16:rowId xmlns:a16="http://schemas.microsoft.com/office/drawing/2014/main" val="10009"/>
+                  </a:ext>
+                </a:extLst>
               </a:tr>
             </a:tbl>
           </a:graphicData>
@@ -5259,7 +5422,7 @@
 </file>
 
 <file path=ppt/slides/slide14.xml><?xml version="1.0" encoding="utf-8"?>
-<p:sld xmlns:a="http://schemas.openxmlformats.org/drawingml/2006/main" xmlns:p="http://schemas.openxmlformats.org/presentationml/2006/main" xmlns:r="http://schemas.openxmlformats.org/officeDocument/2006/relationships">
+<p:sld xmlns:a="http://schemas.openxmlformats.org/drawingml/2006/main" xmlns:r="http://schemas.openxmlformats.org/officeDocument/2006/relationships" xmlns:p="http://schemas.openxmlformats.org/presentationml/2006/main">
   <p:cSld>
     <p:spTree>
       <p:nvGrpSpPr>
@@ -5267,7 +5430,14 @@
         <p:cNvGrpSpPr/>
         <p:nvPr/>
       </p:nvGrpSpPr>
-      <p:grpSpPr/>
+      <p:grpSpPr>
+        <a:xfrm>
+          <a:off x="0" y="0"/>
+          <a:ext cx="0" cy="0"/>
+          <a:chOff x="0" y="0"/>
+          <a:chExt cx="0" cy="0"/>
+        </a:xfrm>
+      </p:grpSpPr>
       <p:sp>
         <p:nvSpPr>
           <p:cNvPr id="2" name="Rectangle 1"/>
@@ -5308,6 +5478,7 @@
           <a:lstStyle/>
           <a:p>
             <a:pPr algn="ctr"/>
+            <a:endParaRPr/>
           </a:p>
         </p:txBody>
       </p:sp>
@@ -5328,7 +5499,7 @@
           <a:noFill/>
         </p:spPr>
         <p:txBody>
-          <a:bodyPr wrap="none" lIns="0" rIns="0" tIns="0" bIns="0">
+          <a:bodyPr wrap="none" lIns="0" tIns="0" rIns="0" bIns="0">
             <a:spAutoFit/>
           </a:bodyPr>
           <a:lstStyle/>
@@ -5363,7 +5534,7 @@
           <a:noFill/>
         </p:spPr>
         <p:txBody>
-          <a:bodyPr wrap="none" lIns="0" rIns="0" tIns="0" bIns="0">
+          <a:bodyPr wrap="none" lIns="0" tIns="0" rIns="0" bIns="0">
             <a:spAutoFit/>
           </a:bodyPr>
           <a:lstStyle/>
@@ -5422,11 +5593,17 @@
           <p:cNvGraphicFramePr>
             <a:graphicFrameLocks noGrp="1"/>
           </p:cNvGraphicFramePr>
-          <p:nvPr/>
+          <p:nvPr>
+            <p:extLst>
+              <p:ext uri="{D42A27DB-BD31-4B8C-83A1-F6EECF244321}">
+                <p14:modId xmlns:p14="http://schemas.microsoft.com/office/powerpoint/2010/main" val="3259441702"/>
+              </p:ext>
+            </p:extLst>
+          </p:nvPr>
         </p:nvGraphicFramePr>
         <p:xfrm>
-          <a:off x="457200" y="1691640"/>
-          <a:ext cx="11277295" cy="2194560"/>
+          <a:off x="378570" y="1575725"/>
+          <a:ext cx="11434859" cy="2884824"/>
         </p:xfrm>
         <a:graphic>
           <a:graphicData uri="http://schemas.openxmlformats.org/drawingml/2006/table">
@@ -5435,12 +5612,36 @@
                 <a:tableStyleId>{5C22544A-7EE6-4342-B048-85BDC9FD1C3A}</a:tableStyleId>
               </a:tblPr>
               <a:tblGrid>
-                <a:gridCol w="2819323"/>
-                <a:gridCol w="2819323"/>
-                <a:gridCol w="2819323"/>
-                <a:gridCol w="2819326"/>
+                <a:gridCol w="2858714">
+                  <a:extLst>
+                    <a:ext uri="{9D8B030D-6E8A-4147-A177-3AD203B41FA5}">
+                      <a16:colId xmlns:a16="http://schemas.microsoft.com/office/drawing/2014/main" val="20000"/>
+                    </a:ext>
+                  </a:extLst>
+                </a:gridCol>
+                <a:gridCol w="2858714">
+                  <a:extLst>
+                    <a:ext uri="{9D8B030D-6E8A-4147-A177-3AD203B41FA5}">
+                      <a16:colId xmlns:a16="http://schemas.microsoft.com/office/drawing/2014/main" val="20001"/>
+                    </a:ext>
+                  </a:extLst>
+                </a:gridCol>
+                <a:gridCol w="2858714">
+                  <a:extLst>
+                    <a:ext uri="{9D8B030D-6E8A-4147-A177-3AD203B41FA5}">
+                      <a16:colId xmlns:a16="http://schemas.microsoft.com/office/drawing/2014/main" val="20002"/>
+                    </a:ext>
+                  </a:extLst>
+                </a:gridCol>
+                <a:gridCol w="2858717">
+                  <a:extLst>
+                    <a:ext uri="{9D8B030D-6E8A-4147-A177-3AD203B41FA5}">
+                      <a16:colId xmlns:a16="http://schemas.microsoft.com/office/drawing/2014/main" val="20003"/>
+                    </a:ext>
+                  </a:extLst>
+                </a:gridCol>
               </a:tblGrid>
-              <a:tr h="548640">
+              <a:tr h="721206">
                 <a:tc>
                   <a:txBody>
                     <a:bodyPr/>
@@ -5533,8 +5734,13 @@
                     </a:solidFill>
                   </a:tcPr>
                 </a:tc>
+                <a:extLst>
+                  <a:ext uri="{0D108BD9-81ED-4DB2-BD59-A6C34878D82A}">
+                    <a16:rowId xmlns:a16="http://schemas.microsoft.com/office/drawing/2014/main" val="10000"/>
+                  </a:ext>
+                </a:extLst>
               </a:tr>
-              <a:tr h="548640">
+              <a:tr h="721206">
                 <a:tc>
                   <a:txBody>
                     <a:bodyPr/>
@@ -5627,8 +5833,13 @@
                     </a:solidFill>
                   </a:tcPr>
                 </a:tc>
+                <a:extLst>
+                  <a:ext uri="{0D108BD9-81ED-4DB2-BD59-A6C34878D82A}">
+                    <a16:rowId xmlns:a16="http://schemas.microsoft.com/office/drawing/2014/main" val="10001"/>
+                  </a:ext>
+                </a:extLst>
               </a:tr>
-              <a:tr h="548640">
+              <a:tr h="721206">
                 <a:tc>
                   <a:txBody>
                     <a:bodyPr/>
@@ -5659,14 +5870,29 @@
                     <a:p>
                       <a:pPr algn="l"/>
                       <a:r>
-                        <a:rPr sz="1200">
-                          <a:solidFill>
-                            <a:srgbClr val="1E293B"/>
-                          </a:solidFill>
-                          <a:latin typeface="Calibri"/>
-                        </a:rPr>
-                        <a:t>Best-deep ≥ 1.10 × best-non-deep on genre_NMI</a:t>
-                      </a:r>
+                        <a:rPr sz="1200" dirty="0">
+                          <a:solidFill>
+                            <a:srgbClr val="1E293B"/>
+                          </a:solidFill>
+                          <a:latin typeface="Calibri"/>
+                        </a:rPr>
+                        <a:t>Best-deep ≥ 1.10 × best-non-deep on </a:t>
+                      </a:r>
+                      <a:r>
+                        <a:rPr sz="1200" dirty="0" err="1">
+                          <a:solidFill>
+                            <a:srgbClr val="1E293B"/>
+                          </a:solidFill>
+                          <a:latin typeface="Calibri"/>
+                        </a:rPr>
+                        <a:t>genre_NMI</a:t>
+                      </a:r>
+                      <a:endParaRPr sz="1200" dirty="0">
+                        <a:solidFill>
+                          <a:srgbClr val="1E293B"/>
+                        </a:solidFill>
+                        <a:latin typeface="Calibri"/>
+                      </a:endParaRPr>
                     </a:p>
                   </a:txBody>
                   <a:tcPr>
@@ -5721,8 +5947,13 @@
                     </a:solidFill>
                   </a:tcPr>
                 </a:tc>
+                <a:extLst>
+                  <a:ext uri="{0D108BD9-81ED-4DB2-BD59-A6C34878D82A}">
+                    <a16:rowId xmlns:a16="http://schemas.microsoft.com/office/drawing/2014/main" val="10002"/>
+                  </a:ext>
+                </a:extLst>
               </a:tr>
-              <a:tr h="548640">
+              <a:tr h="721206">
                 <a:tc>
                   <a:txBody>
                     <a:bodyPr/>
@@ -5799,7 +6030,7 @@
                     <a:p>
                       <a:pPr algn="l"/>
                       <a:r>
-                        <a:rPr sz="1200">
+                        <a:rPr sz="1200" dirty="0">
                           <a:solidFill>
                             <a:srgbClr val="1E293B"/>
                           </a:solidFill>
@@ -5815,6 +6046,11 @@
                     </a:solidFill>
                   </a:tcPr>
                 </a:tc>
+                <a:extLst>
+                  <a:ext uri="{0D108BD9-81ED-4DB2-BD59-A6C34878D82A}">
+                    <a16:rowId xmlns:a16="http://schemas.microsoft.com/office/drawing/2014/main" val="10003"/>
+                  </a:ext>
+                </a:extLst>
               </a:tr>
             </a:tbl>
           </a:graphicData>
@@ -5828,8 +6064,8 @@
         </p:nvSpPr>
         <p:spPr>
           <a:xfrm>
-            <a:off x="457200" y="4206240"/>
-            <a:ext cx="11277295" cy="1097280"/>
+            <a:off x="299636" y="4576465"/>
+            <a:ext cx="11277295" cy="830997"/>
           </a:xfrm>
           <a:prstGeom prst="rect">
             <a:avLst/>
@@ -5844,13 +6080,67 @@
           <a:p>
             <a:pPr algn="ctr"/>
             <a:r>
-              <a:rPr sz="2200">
+              <a:rPr sz="2400" dirty="0">
                 <a:solidFill>
                   <a:srgbClr val="C2410C"/>
                 </a:solidFill>
                 <a:latin typeface="Calibri Light"/>
               </a:rPr>
-              <a:t>Best model: dec_z64_k21  —  genre_NMI = 0.332,  lang_NMI = 0.294,  decade_NMI = 0.342</a:t>
+              <a:t>Best model: dec_z64_k21  —  </a:t>
+            </a:r>
+            <a:r>
+              <a:rPr sz="2400" dirty="0" err="1">
+                <a:solidFill>
+                  <a:srgbClr val="C2410C"/>
+                </a:solidFill>
+                <a:latin typeface="Calibri Light"/>
+              </a:rPr>
+              <a:t>genre_NMI</a:t>
+            </a:r>
+            <a:r>
+              <a:rPr sz="2400" dirty="0">
+                <a:solidFill>
+                  <a:srgbClr val="C2410C"/>
+                </a:solidFill>
+                <a:latin typeface="Calibri Light"/>
+              </a:rPr>
+              <a:t> = 0.332,  </a:t>
+            </a:r>
+            <a:r>
+              <a:rPr sz="2400" dirty="0" err="1">
+                <a:solidFill>
+                  <a:srgbClr val="C2410C"/>
+                </a:solidFill>
+                <a:latin typeface="Calibri Light"/>
+              </a:rPr>
+              <a:t>lang_NMI</a:t>
+            </a:r>
+            <a:r>
+              <a:rPr sz="2400" dirty="0">
+                <a:solidFill>
+                  <a:srgbClr val="C2410C"/>
+                </a:solidFill>
+                <a:latin typeface="Calibri Light"/>
+              </a:rPr>
+              <a:t> = 0.294,  </a:t>
+            </a:r>
+            <a:r>
+              <a:rPr sz="2400" dirty="0" err="1">
+                <a:solidFill>
+                  <a:srgbClr val="C2410C"/>
+                </a:solidFill>
+                <a:latin typeface="Calibri Light"/>
+              </a:rPr>
+              <a:t>decade_NMI</a:t>
+            </a:r>
+            <a:r>
+              <a:rPr sz="2400" dirty="0">
+                <a:solidFill>
+                  <a:srgbClr val="C2410C"/>
+                </a:solidFill>
+                <a:latin typeface="Calibri Light"/>
+              </a:rPr>
+              <a:t> = 0.342</a:t>
             </a:r>
           </a:p>
         </p:txBody>
@@ -5863,8 +6153,8 @@
         </p:nvSpPr>
         <p:spPr>
           <a:xfrm>
-            <a:off x="457200" y="5669280"/>
-            <a:ext cx="11277295" cy="457200"/>
+            <a:off x="-818707" y="5780730"/>
+            <a:ext cx="13513982" cy="461665"/>
           </a:xfrm>
           <a:prstGeom prst="rect">
             <a:avLst/>
@@ -5872,20 +6162,65 @@
           <a:noFill/>
         </p:spPr>
         <p:txBody>
-          <a:bodyPr wrap="none">
+          <a:bodyPr wrap="square">
             <a:spAutoFit/>
           </a:bodyPr>
           <a:lstStyle/>
           <a:p>
             <a:pPr algn="ctr"/>
             <a:r>
-              <a:rPr sz="1600">
+              <a:rPr sz="2400" dirty="0" err="1">
                 <a:solidFill>
                   <a:srgbClr val="64748B"/>
                 </a:solidFill>
                 <a:latin typeface="Calibri"/>
               </a:rPr>
-              <a:t>github.com/barandincoguz/CineEmbed-     ·     Thank you. Questions?</a:t>
+              <a:t>github.com</a:t>
+            </a:r>
+            <a:r>
+              <a:rPr sz="2400" dirty="0">
+                <a:solidFill>
+                  <a:srgbClr val="64748B"/>
+                </a:solidFill>
+                <a:latin typeface="Calibri"/>
+              </a:rPr>
+              <a:t>/</a:t>
+            </a:r>
+            <a:r>
+              <a:rPr sz="2400" dirty="0" err="1">
+                <a:solidFill>
+                  <a:srgbClr val="64748B"/>
+                </a:solidFill>
+                <a:latin typeface="Calibri"/>
+              </a:rPr>
+              <a:t>barandincoguz</a:t>
+            </a:r>
+            <a:r>
+              <a:rPr sz="2400" dirty="0">
+                <a:solidFill>
+                  <a:srgbClr val="64748B"/>
+                </a:solidFill>
+                <a:latin typeface="Calibri"/>
+              </a:rPr>
+              <a:t>/</a:t>
+            </a:r>
+            <a:r>
+              <a:rPr sz="2400" dirty="0" err="1">
+                <a:solidFill>
+                  <a:srgbClr val="64748B"/>
+                </a:solidFill>
+                <a:latin typeface="Calibri"/>
+              </a:rPr>
+              <a:t>CineEmbed</a:t>
+            </a:r>
+            <a:r>
+              <a:rPr sz="2400" dirty="0">
+                <a:solidFill>
+                  <a:srgbClr val="64748B"/>
+                </a:solidFill>
+                <a:latin typeface="Calibri"/>
+              </a:rPr>
+              <a:t>-     ·     Thank you. Questions?</a:t>
             </a:r>
           </a:p>
         </p:txBody>
@@ -5899,7 +6234,7 @@
 </file>
 
 <file path=ppt/slides/slide2.xml><?xml version="1.0" encoding="utf-8"?>
-<p:sld xmlns:a="http://schemas.openxmlformats.org/drawingml/2006/main" xmlns:p="http://schemas.openxmlformats.org/presentationml/2006/main" xmlns:r="http://schemas.openxmlformats.org/officeDocument/2006/relationships">
+<p:sld xmlns:a="http://schemas.openxmlformats.org/drawingml/2006/main" xmlns:r="http://schemas.openxmlformats.org/officeDocument/2006/relationships" xmlns:p="http://schemas.openxmlformats.org/presentationml/2006/main">
   <p:cSld>
     <p:spTree>
       <p:nvGrpSpPr>
@@ -5907,7 +6242,14 @@
         <p:cNvGrpSpPr/>
         <p:nvPr/>
       </p:nvGrpSpPr>
-      <p:grpSpPr/>
+      <p:grpSpPr>
+        <a:xfrm>
+          <a:off x="0" y="0"/>
+          <a:ext cx="0" cy="0"/>
+          <a:chOff x="0" y="0"/>
+          <a:chExt cx="0" cy="0"/>
+        </a:xfrm>
+      </p:grpSpPr>
       <p:sp>
         <p:nvSpPr>
           <p:cNvPr id="2" name="Rectangle 1"/>
@@ -5948,6 +6290,7 @@
           <a:lstStyle/>
           <a:p>
             <a:pPr algn="ctr"/>
+            <a:endParaRPr/>
           </a:p>
         </p:txBody>
       </p:sp>
@@ -5960,7 +6303,7 @@
         <p:spPr>
           <a:xfrm>
             <a:off x="457200" y="274320"/>
-            <a:ext cx="11277295" cy="685800"/>
+            <a:ext cx="4799968" cy="615553"/>
           </a:xfrm>
           <a:prstGeom prst="rect">
             <a:avLst/>
@@ -5968,20 +6311,38 @@
           <a:noFill/>
         </p:spPr>
         <p:txBody>
-          <a:bodyPr wrap="none" lIns="0" rIns="0" tIns="0" bIns="0">
+          <a:bodyPr wrap="none" lIns="0" tIns="0" rIns="0" bIns="0">
             <a:spAutoFit/>
           </a:bodyPr>
           <a:lstStyle/>
           <a:p>
             <a:pPr algn="l"/>
             <a:r>
-              <a:rPr sz="3600" b="0">
+              <a:rPr sz="3600" b="0" dirty="0">
                 <a:solidFill>
                   <a:srgbClr val="C2410C"/>
                 </a:solidFill>
                 <a:latin typeface="Calibri Light"/>
               </a:rPr>
-              <a:t>Project Status: ON TRACK</a:t>
+              <a:t>Project </a:t>
+            </a:r>
+            <a:r>
+              <a:rPr sz="4000" b="0" dirty="0">
+                <a:solidFill>
+                  <a:srgbClr val="C2410C"/>
+                </a:solidFill>
+                <a:latin typeface="Calibri Light"/>
+              </a:rPr>
+              <a:t>Status</a:t>
+            </a:r>
+            <a:r>
+              <a:rPr sz="3600" b="0" dirty="0">
+                <a:solidFill>
+                  <a:srgbClr val="C2410C"/>
+                </a:solidFill>
+                <a:latin typeface="Calibri Light"/>
+              </a:rPr>
+              <a:t>: ON TRACK</a:t>
             </a:r>
           </a:p>
         </p:txBody>
@@ -5995,7 +6356,7 @@
         <p:spPr>
           <a:xfrm>
             <a:off x="457200" y="914400"/>
-            <a:ext cx="11277295" cy="365760"/>
+            <a:ext cx="7206203" cy="369332"/>
           </a:xfrm>
           <a:prstGeom prst="rect">
             <a:avLst/>
@@ -6003,14 +6364,14 @@
           <a:noFill/>
         </p:spPr>
         <p:txBody>
-          <a:bodyPr wrap="none" lIns="0" rIns="0" tIns="0" bIns="0">
+          <a:bodyPr wrap="none" lIns="0" tIns="0" rIns="0" bIns="0">
             <a:spAutoFit/>
           </a:bodyPr>
           <a:lstStyle/>
           <a:p>
             <a:pPr algn="l"/>
             <a:r>
-              <a:rPr sz="2000">
+              <a:rPr sz="2400" dirty="0">
                 <a:solidFill>
                   <a:srgbClr val="64748B"/>
                 </a:solidFill>
@@ -6030,7 +6391,7 @@
         <p:spPr>
           <a:xfrm>
             <a:off x="457200" y="6537960"/>
-            <a:ext cx="11277295" cy="228600"/>
+            <a:ext cx="1981312" cy="246221"/>
           </a:xfrm>
           <a:prstGeom prst="rect">
             <a:avLst/>
@@ -6094,7 +6455,7 @@
           </a:fontRef>
         </p:style>
         <p:txBody>
-          <a:bodyPr rtlCol="0" anchor="ctr" tIns="0" bIns="0"/>
+          <a:bodyPr tIns="0" bIns="0" rtlCol="0" anchor="ctr"/>
           <a:lstStyle/>
           <a:p>
             <a:pPr algn="ctr"/>
@@ -6119,7 +6480,7 @@
         <p:spPr>
           <a:xfrm>
             <a:off x="457200" y="2057400"/>
-            <a:ext cx="6400800" cy="3200400"/>
+            <a:ext cx="6400800" cy="3554819"/>
           </a:xfrm>
           <a:prstGeom prst="rect">
             <a:avLst/>
@@ -6127,7 +6488,7 @@
           <a:noFill/>
         </p:spPr>
         <p:txBody>
-          <a:bodyPr wrap="square" lIns="0" rIns="0" tIns="0" bIns="0">
+          <a:bodyPr wrap="square" lIns="0" tIns="0" rIns="0" bIns="0">
             <a:spAutoFit/>
           </a:bodyPr>
           <a:lstStyle/>
@@ -6138,7 +6499,7 @@
               </a:spcAft>
             </a:pPr>
             <a:r>
-              <a:rPr sz="1800">
+              <a:rPr sz="2400" dirty="0">
                 <a:solidFill>
                   <a:srgbClr val="1E293B"/>
                 </a:solidFill>
@@ -6154,13 +6515,31 @@
               </a:spcAft>
             </a:pPr>
             <a:r>
-              <a:rPr sz="1800">
+              <a:rPr sz="2400" dirty="0">
                 <a:solidFill>
                   <a:srgbClr val="1E293B"/>
                 </a:solidFill>
                 <a:latin typeface="Calibri"/>
               </a:rPr>
-              <a:t>•  Best deep model dec_z64_k21 reaches genre_NMI = 0.332, +205 % over best non-deep baseline.</a:t>
+              <a:t>•  Best deep model dec_z64_k21 reaches </a:t>
+            </a:r>
+            <a:r>
+              <a:rPr sz="2400" dirty="0" err="1">
+                <a:solidFill>
+                  <a:srgbClr val="1E293B"/>
+                </a:solidFill>
+                <a:latin typeface="Calibri"/>
+              </a:rPr>
+              <a:t>genre_NMI</a:t>
+            </a:r>
+            <a:r>
+              <a:rPr sz="2400" dirty="0">
+                <a:solidFill>
+                  <a:srgbClr val="1E293B"/>
+                </a:solidFill>
+                <a:latin typeface="Calibri"/>
+              </a:rPr>
+              <a:t> = 0.332, +205 % over best non-deep baseline.</a:t>
             </a:r>
           </a:p>
           <a:p>
@@ -6170,7 +6549,7 @@
               </a:spcAft>
             </a:pPr>
             <a:r>
-              <a:rPr sz="1800">
+              <a:rPr sz="2400" dirty="0">
                 <a:solidFill>
                   <a:srgbClr val="1E293B"/>
                 </a:solidFill>
@@ -6186,7 +6565,7 @@
               </a:spcAft>
             </a:pPr>
             <a:r>
-              <a:rPr sz="1800">
+              <a:rPr sz="2400" dirty="0">
                 <a:solidFill>
                   <a:srgbClr val="1E293B"/>
                 </a:solidFill>
@@ -6205,8 +6584,8 @@
         </p:nvSpPr>
         <p:spPr>
           <a:xfrm>
-            <a:off x="6858000" y="2011680"/>
-            <a:ext cx="4937760" cy="2377440"/>
+            <a:off x="6960847" y="2238598"/>
+            <a:ext cx="4732065" cy="1923604"/>
           </a:xfrm>
           <a:prstGeom prst="rect">
             <a:avLst/>
@@ -6214,14 +6593,14 @@
           <a:noFill/>
         </p:spPr>
         <p:txBody>
-          <a:bodyPr wrap="none" lIns="0" rIns="0" tIns="0" bIns="0" anchor="ctr">
+          <a:bodyPr wrap="none" lIns="0" tIns="0" rIns="0" bIns="0" anchor="ctr">
             <a:spAutoFit/>
           </a:bodyPr>
           <a:lstStyle/>
           <a:p>
             <a:pPr algn="ctr"/>
             <a:r>
-              <a:rPr sz="18000" b="0">
+              <a:rPr sz="12500" b="0" dirty="0">
                 <a:solidFill>
                   <a:srgbClr val="C2410C"/>
                 </a:solidFill>
@@ -6241,7 +6620,7 @@
         <p:spPr>
           <a:xfrm>
             <a:off x="6858000" y="4480560"/>
-            <a:ext cx="4937760" cy="731520"/>
+            <a:ext cx="4937760" cy="553998"/>
           </a:xfrm>
           <a:prstGeom prst="rect">
             <a:avLst/>
@@ -6249,14 +6628,14 @@
           <a:noFill/>
         </p:spPr>
         <p:txBody>
-          <a:bodyPr wrap="square" lIns="0" rIns="0" tIns="0" bIns="0">
+          <a:bodyPr wrap="square" lIns="0" tIns="0" rIns="0" bIns="0">
             <a:spAutoFit/>
           </a:bodyPr>
           <a:lstStyle/>
           <a:p>
             <a:pPr algn="ctr"/>
             <a:r>
-              <a:rPr sz="1800">
+              <a:rPr>
                 <a:solidFill>
                   <a:srgbClr val="64748B"/>
                 </a:solidFill>
@@ -6276,7 +6655,7 @@
 </file>
 
 <file path=ppt/slides/slide3.xml><?xml version="1.0" encoding="utf-8"?>
-<p:sld xmlns:a="http://schemas.openxmlformats.org/drawingml/2006/main" xmlns:p="http://schemas.openxmlformats.org/presentationml/2006/main" xmlns:r="http://schemas.openxmlformats.org/officeDocument/2006/relationships">
+<p:sld xmlns:a="http://schemas.openxmlformats.org/drawingml/2006/main" xmlns:r="http://schemas.openxmlformats.org/officeDocument/2006/relationships" xmlns:p="http://schemas.openxmlformats.org/presentationml/2006/main">
   <p:cSld>
     <p:spTree>
       <p:nvGrpSpPr>
@@ -6284,7 +6663,14 @@
         <p:cNvGrpSpPr/>
         <p:nvPr/>
       </p:nvGrpSpPr>
-      <p:grpSpPr/>
+      <p:grpSpPr>
+        <a:xfrm>
+          <a:off x="0" y="0"/>
+          <a:ext cx="0" cy="0"/>
+          <a:chOff x="0" y="0"/>
+          <a:chExt cx="0" cy="0"/>
+        </a:xfrm>
+      </p:grpSpPr>
       <p:sp>
         <p:nvSpPr>
           <p:cNvPr id="2" name="Rectangle 1"/>
@@ -6325,6 +6711,7 @@
           <a:lstStyle/>
           <a:p>
             <a:pPr algn="ctr"/>
+            <a:endParaRPr/>
           </a:p>
         </p:txBody>
       </p:sp>
@@ -6345,7 +6732,7 @@
           <a:noFill/>
         </p:spPr>
         <p:txBody>
-          <a:bodyPr wrap="none" lIns="0" rIns="0" tIns="0" bIns="0">
+          <a:bodyPr wrap="none" lIns="0" tIns="0" rIns="0" bIns="0">
             <a:spAutoFit/>
           </a:bodyPr>
           <a:lstStyle/>
@@ -6380,7 +6767,7 @@
           <a:noFill/>
         </p:spPr>
         <p:txBody>
-          <a:bodyPr wrap="none" lIns="0" rIns="0" tIns="0" bIns="0">
+          <a:bodyPr wrap="none" lIns="0" tIns="0" rIns="0" bIns="0">
             <a:spAutoFit/>
           </a:bodyPr>
           <a:lstStyle/>
@@ -6441,8 +6828,8 @@
         </p:nvSpPr>
         <p:spPr>
           <a:xfrm>
-            <a:off x="457200" y="1554480"/>
-            <a:ext cx="6858000" cy="4572000"/>
+            <a:off x="287079" y="1600200"/>
+            <a:ext cx="5209953" cy="3385542"/>
           </a:xfrm>
           <a:prstGeom prst="rect">
             <a:avLst/>
@@ -6450,18 +6837,18 @@
           <a:noFill/>
         </p:spPr>
         <p:txBody>
-          <a:bodyPr wrap="square" lIns="0" rIns="0" tIns="0" bIns="0">
+          <a:bodyPr wrap="square" lIns="0" tIns="0" rIns="0" bIns="0">
             <a:spAutoFit/>
           </a:bodyPr>
           <a:lstStyle/>
           <a:p>
-            <a:pPr algn="l">
+            <a:pPr>
               <a:spcAft>
                 <a:spcPts val="600"/>
               </a:spcAft>
             </a:pPr>
             <a:r>
-              <a:rPr sz="1800">
+              <a:rPr sz="2000" dirty="0">
                 <a:solidFill>
                   <a:srgbClr val="1E293B"/>
                 </a:solidFill>
@@ -6471,13 +6858,13 @@
             </a:r>
           </a:p>
           <a:p>
-            <a:pPr algn="l">
+            <a:pPr>
               <a:spcAft>
                 <a:spcPts val="600"/>
               </a:spcAft>
             </a:pPr>
             <a:r>
-              <a:rPr sz="1800">
+              <a:rPr sz="2000" dirty="0">
                 <a:solidFill>
                   <a:srgbClr val="1E293B"/>
                 </a:solidFill>
@@ -6487,13 +6874,13 @@
             </a:r>
           </a:p>
           <a:p>
-            <a:pPr algn="l">
+            <a:pPr>
               <a:spcAft>
                 <a:spcPts val="600"/>
               </a:spcAft>
             </a:pPr>
             <a:r>
-              <a:rPr sz="1800">
+              <a:rPr sz="2000" dirty="0">
                 <a:solidFill>
                   <a:srgbClr val="1E293B"/>
                 </a:solidFill>
@@ -6503,13 +6890,13 @@
             </a:r>
           </a:p>
           <a:p>
-            <a:pPr algn="l">
+            <a:pPr>
               <a:spcAft>
                 <a:spcPts val="600"/>
               </a:spcAft>
             </a:pPr>
             <a:r>
-              <a:rPr sz="1800">
+              <a:rPr sz="2000" dirty="0">
                 <a:solidFill>
                   <a:srgbClr val="1E293B"/>
                 </a:solidFill>
@@ -6519,19 +6906,37 @@
             </a:r>
           </a:p>
           <a:p>
-            <a:pPr algn="l">
+            <a:pPr>
               <a:spcAft>
                 <a:spcPts val="600"/>
               </a:spcAft>
             </a:pPr>
             <a:r>
-              <a:rPr sz="1800">
+              <a:rPr sz="2000" dirty="0">
                 <a:solidFill>
                   <a:srgbClr val="1E293B"/>
                 </a:solidFill>
                 <a:latin typeface="Calibri"/>
               </a:rPr>
-              <a:t>•  Evaluate via KMeans clustering of the latent → NMI / ARI.</a:t>
+              <a:t>•  Evaluate via </a:t>
+            </a:r>
+            <a:r>
+              <a:rPr sz="2000" dirty="0" err="1">
+                <a:solidFill>
+                  <a:srgbClr val="1E293B"/>
+                </a:solidFill>
+                <a:latin typeface="Calibri"/>
+              </a:rPr>
+              <a:t>KMeans</a:t>
+            </a:r>
+            <a:r>
+              <a:rPr sz="2000" dirty="0">
+                <a:solidFill>
+                  <a:srgbClr val="1E293B"/>
+                </a:solidFill>
+                <a:latin typeface="Calibri"/>
+              </a:rPr>
+              <a:t> clustering of the latent → NMI / ARI.</a:t>
             </a:r>
           </a:p>
         </p:txBody>
@@ -6542,11 +6947,17 @@
           <p:cNvGraphicFramePr>
             <a:graphicFrameLocks noGrp="1"/>
           </p:cNvGraphicFramePr>
-          <p:nvPr/>
+          <p:nvPr>
+            <p:extLst>
+              <p:ext uri="{D42A27DB-BD31-4B8C-83A1-F6EECF244321}">
+                <p14:modId xmlns:p14="http://schemas.microsoft.com/office/powerpoint/2010/main" val="118489846"/>
+              </p:ext>
+            </p:extLst>
+          </p:nvPr>
         </p:nvGraphicFramePr>
         <p:xfrm>
-          <a:off x="7498079" y="1508760"/>
-          <a:ext cx="4297680" cy="3291840"/>
+          <a:off x="5592727" y="1508758"/>
+          <a:ext cx="6203031" cy="4594330"/>
         </p:xfrm>
         <a:graphic>
           <a:graphicData uri="http://schemas.openxmlformats.org/drawingml/2006/table">
@@ -6555,11 +6966,29 @@
                 <a:tableStyleId>{5C22544A-7EE6-4342-B048-85BDC9FD1C3A}</a:tableStyleId>
               </a:tblPr>
               <a:tblGrid>
-                <a:gridCol w="1432560"/>
-                <a:gridCol w="1432560"/>
-                <a:gridCol w="1432560"/>
+                <a:gridCol w="2067677">
+                  <a:extLst>
+                    <a:ext uri="{9D8B030D-6E8A-4147-A177-3AD203B41FA5}">
+                      <a16:colId xmlns:a16="http://schemas.microsoft.com/office/drawing/2014/main" val="20000"/>
+                    </a:ext>
+                  </a:extLst>
+                </a:gridCol>
+                <a:gridCol w="2067677">
+                  <a:extLst>
+                    <a:ext uri="{9D8B030D-6E8A-4147-A177-3AD203B41FA5}">
+                      <a16:colId xmlns:a16="http://schemas.microsoft.com/office/drawing/2014/main" val="20001"/>
+                    </a:ext>
+                  </a:extLst>
+                </a:gridCol>
+                <a:gridCol w="2067677">
+                  <a:extLst>
+                    <a:ext uri="{9D8B030D-6E8A-4147-A177-3AD203B41FA5}">
+                      <a16:colId xmlns:a16="http://schemas.microsoft.com/office/drawing/2014/main" val="20002"/>
+                    </a:ext>
+                  </a:extLst>
+                </a:gridCol>
               </a:tblGrid>
-              <a:tr h="411480">
+              <a:tr h="530114">
                 <a:tc>
                   <a:txBody>
                     <a:bodyPr/>
@@ -6629,8 +7058,13 @@
                     </a:solidFill>
                   </a:tcPr>
                 </a:tc>
+                <a:extLst>
+                  <a:ext uri="{0D108BD9-81ED-4DB2-BD59-A6C34878D82A}">
+                    <a16:rowId xmlns:a16="http://schemas.microsoft.com/office/drawing/2014/main" val="10000"/>
+                  </a:ext>
+                </a:extLst>
               </a:tr>
-              <a:tr h="411480">
+              <a:tr h="589017">
                 <a:tc>
                   <a:txBody>
                     <a:bodyPr/>
@@ -6700,8 +7134,13 @@
                     </a:solidFill>
                   </a:tcPr>
                 </a:tc>
+                <a:extLst>
+                  <a:ext uri="{0D108BD9-81ED-4DB2-BD59-A6C34878D82A}">
+                    <a16:rowId xmlns:a16="http://schemas.microsoft.com/office/drawing/2014/main" val="10001"/>
+                  </a:ext>
+                </a:extLst>
               </a:tr>
-              <a:tr h="411480">
+              <a:tr h="589017">
                 <a:tc>
                   <a:txBody>
                     <a:bodyPr/>
@@ -6771,8 +7210,13 @@
                     </a:solidFill>
                   </a:tcPr>
                 </a:tc>
+                <a:extLst>
+                  <a:ext uri="{0D108BD9-81ED-4DB2-BD59-A6C34878D82A}">
+                    <a16:rowId xmlns:a16="http://schemas.microsoft.com/office/drawing/2014/main" val="10002"/>
+                  </a:ext>
+                </a:extLst>
               </a:tr>
-              <a:tr h="411480">
+              <a:tr h="589017">
                 <a:tc>
                   <a:txBody>
                     <a:bodyPr/>
@@ -6842,16 +7286,21 @@
                     </a:solidFill>
                   </a:tcPr>
                 </a:tc>
+                <a:extLst>
+                  <a:ext uri="{0D108BD9-81ED-4DB2-BD59-A6C34878D82A}">
+                    <a16:rowId xmlns:a16="http://schemas.microsoft.com/office/drawing/2014/main" val="10003"/>
+                  </a:ext>
+                </a:extLst>
               </a:tr>
-              <a:tr h="411480">
-                <a:tc>
-                  <a:txBody>
-                    <a:bodyPr/>
-                    <a:lstStyle/>
-                    <a:p>
-                      <a:pPr algn="l"/>
-                      <a:r>
-                        <a:rPr sz="1200">
+              <a:tr h="530114">
+                <a:tc>
+                  <a:txBody>
+                    <a:bodyPr/>
+                    <a:lstStyle/>
+                    <a:p>
+                      <a:pPr algn="l"/>
+                      <a:r>
+                        <a:rPr sz="1200" dirty="0">
                           <a:solidFill>
                             <a:srgbClr val="1E293B"/>
                           </a:solidFill>
@@ -6913,16 +7362,21 @@
                     </a:solidFill>
                   </a:tcPr>
                 </a:tc>
+                <a:extLst>
+                  <a:ext uri="{0D108BD9-81ED-4DB2-BD59-A6C34878D82A}">
+                    <a16:rowId xmlns:a16="http://schemas.microsoft.com/office/drawing/2014/main" val="10004"/>
+                  </a:ext>
+                </a:extLst>
               </a:tr>
-              <a:tr h="411480">
-                <a:tc>
-                  <a:txBody>
-                    <a:bodyPr/>
-                    <a:lstStyle/>
-                    <a:p>
-                      <a:pPr algn="l"/>
-                      <a:r>
-                        <a:rPr sz="1200">
+              <a:tr h="589017">
+                <a:tc>
+                  <a:txBody>
+                    <a:bodyPr/>
+                    <a:lstStyle/>
+                    <a:p>
+                      <a:pPr algn="l"/>
+                      <a:r>
+                        <a:rPr sz="1200" dirty="0">
                           <a:solidFill>
                             <a:srgbClr val="1E293B"/>
                           </a:solidFill>
@@ -6984,8 +7438,13 @@
                     </a:solidFill>
                   </a:tcPr>
                 </a:tc>
+                <a:extLst>
+                  <a:ext uri="{0D108BD9-81ED-4DB2-BD59-A6C34878D82A}">
+                    <a16:rowId xmlns:a16="http://schemas.microsoft.com/office/drawing/2014/main" val="10005"/>
+                  </a:ext>
+                </a:extLst>
               </a:tr>
-              <a:tr h="411480">
+              <a:tr h="589017">
                 <a:tc>
                   <a:txBody>
                     <a:bodyPr/>
@@ -7055,16 +7514,21 @@
                     </a:solidFill>
                   </a:tcPr>
                 </a:tc>
+                <a:extLst>
+                  <a:ext uri="{0D108BD9-81ED-4DB2-BD59-A6C34878D82A}">
+                    <a16:rowId xmlns:a16="http://schemas.microsoft.com/office/drawing/2014/main" val="10006"/>
+                  </a:ext>
+                </a:extLst>
               </a:tr>
-              <a:tr h="411480">
-                <a:tc>
-                  <a:txBody>
-                    <a:bodyPr/>
-                    <a:lstStyle/>
-                    <a:p>
-                      <a:pPr algn="l"/>
-                      <a:r>
-                        <a:rPr sz="1200">
+              <a:tr h="589017">
+                <a:tc>
+                  <a:txBody>
+                    <a:bodyPr/>
+                    <a:lstStyle/>
+                    <a:p>
+                      <a:pPr algn="l"/>
+                      <a:r>
+                        <a:rPr sz="1200" dirty="0">
                           <a:solidFill>
                             <a:srgbClr val="1E293B"/>
                           </a:solidFill>
@@ -7110,7 +7574,7 @@
                     <a:p>
                       <a:pPr algn="l"/>
                       <a:r>
-                        <a:rPr sz="1200">
+                        <a:rPr sz="1200" dirty="0">
                           <a:solidFill>
                             <a:srgbClr val="1E293B"/>
                           </a:solidFill>
@@ -7126,6 +7590,11 @@
                     </a:solidFill>
                   </a:tcPr>
                 </a:tc>
+                <a:extLst>
+                  <a:ext uri="{0D108BD9-81ED-4DB2-BD59-A6C34878D82A}">
+                    <a16:rowId xmlns:a16="http://schemas.microsoft.com/office/drawing/2014/main" val="10007"/>
+                  </a:ext>
+                </a:extLst>
               </a:tr>
             </a:tbl>
           </a:graphicData>
@@ -7140,7 +7609,7 @@
 </file>
 
 <file path=ppt/slides/slide4.xml><?xml version="1.0" encoding="utf-8"?>
-<p:sld xmlns:a="http://schemas.openxmlformats.org/drawingml/2006/main" xmlns:p="http://schemas.openxmlformats.org/presentationml/2006/main" xmlns:r="http://schemas.openxmlformats.org/officeDocument/2006/relationships">
+<p:sld xmlns:a="http://schemas.openxmlformats.org/drawingml/2006/main" xmlns:r="http://schemas.openxmlformats.org/officeDocument/2006/relationships" xmlns:p="http://schemas.openxmlformats.org/presentationml/2006/main">
   <p:cSld>
     <p:spTree>
       <p:nvGrpSpPr>
@@ -7148,7 +7617,14 @@
         <p:cNvGrpSpPr/>
         <p:nvPr/>
       </p:nvGrpSpPr>
-      <p:grpSpPr/>
+      <p:grpSpPr>
+        <a:xfrm>
+          <a:off x="0" y="0"/>
+          <a:ext cx="0" cy="0"/>
+          <a:chOff x="0" y="0"/>
+          <a:chExt cx="0" cy="0"/>
+        </a:xfrm>
+      </p:grpSpPr>
       <p:sp>
         <p:nvSpPr>
           <p:cNvPr id="2" name="Rectangle 1"/>
@@ -7189,6 +7665,7 @@
           <a:lstStyle/>
           <a:p>
             <a:pPr algn="ctr"/>
+            <a:endParaRPr/>
           </a:p>
         </p:txBody>
       </p:sp>
@@ -7209,7 +7686,7 @@
           <a:noFill/>
         </p:spPr>
         <p:txBody>
-          <a:bodyPr wrap="none" lIns="0" rIns="0" tIns="0" bIns="0">
+          <a:bodyPr wrap="none" lIns="0" tIns="0" rIns="0" bIns="0">
             <a:spAutoFit/>
           </a:bodyPr>
           <a:lstStyle/>
@@ -7244,7 +7721,7 @@
           <a:noFill/>
         </p:spPr>
         <p:txBody>
-          <a:bodyPr wrap="none" lIns="0" rIns="0" tIns="0" bIns="0">
+          <a:bodyPr wrap="none" lIns="0" tIns="0" rIns="0" bIns="0">
             <a:spAutoFit/>
           </a:bodyPr>
           <a:lstStyle/>
@@ -7316,10 +7793,34 @@
                 <a:tableStyleId>{5C22544A-7EE6-4342-B048-85BDC9FD1C3A}</a:tableStyleId>
               </a:tblPr>
               <a:tblGrid>
-                <a:gridCol w="2819323"/>
-                <a:gridCol w="2819323"/>
-                <a:gridCol w="2819323"/>
-                <a:gridCol w="2819326"/>
+                <a:gridCol w="2819323">
+                  <a:extLst>
+                    <a:ext uri="{9D8B030D-6E8A-4147-A177-3AD203B41FA5}">
+                      <a16:colId xmlns:a16="http://schemas.microsoft.com/office/drawing/2014/main" val="20000"/>
+                    </a:ext>
+                  </a:extLst>
+                </a:gridCol>
+                <a:gridCol w="2819323">
+                  <a:extLst>
+                    <a:ext uri="{9D8B030D-6E8A-4147-A177-3AD203B41FA5}">
+                      <a16:colId xmlns:a16="http://schemas.microsoft.com/office/drawing/2014/main" val="20001"/>
+                    </a:ext>
+                  </a:extLst>
+                </a:gridCol>
+                <a:gridCol w="2819323">
+                  <a:extLst>
+                    <a:ext uri="{9D8B030D-6E8A-4147-A177-3AD203B41FA5}">
+                      <a16:colId xmlns:a16="http://schemas.microsoft.com/office/drawing/2014/main" val="20002"/>
+                    </a:ext>
+                  </a:extLst>
+                </a:gridCol>
+                <a:gridCol w="2819326">
+                  <a:extLst>
+                    <a:ext uri="{9D8B030D-6E8A-4147-A177-3AD203B41FA5}">
+                      <a16:colId xmlns:a16="http://schemas.microsoft.com/office/drawing/2014/main" val="20003"/>
+                    </a:ext>
+                  </a:extLst>
+                </a:gridCol>
               </a:tblGrid>
               <a:tr h="432261">
                 <a:tc>
@@ -7414,6 +7915,11 @@
                     </a:solidFill>
                   </a:tcPr>
                 </a:tc>
+                <a:extLst>
+                  <a:ext uri="{0D108BD9-81ED-4DB2-BD59-A6C34878D82A}">
+                    <a16:rowId xmlns:a16="http://schemas.microsoft.com/office/drawing/2014/main" val="10000"/>
+                  </a:ext>
+                </a:extLst>
               </a:tr>
               <a:tr h="432261">
                 <a:tc>
@@ -7508,6 +8014,11 @@
                     </a:solidFill>
                   </a:tcPr>
                 </a:tc>
+                <a:extLst>
+                  <a:ext uri="{0D108BD9-81ED-4DB2-BD59-A6C34878D82A}">
+                    <a16:rowId xmlns:a16="http://schemas.microsoft.com/office/drawing/2014/main" val="10001"/>
+                  </a:ext>
+                </a:extLst>
               </a:tr>
               <a:tr h="432261">
                 <a:tc>
@@ -7602,6 +8113,11 @@
                     </a:solidFill>
                   </a:tcPr>
                 </a:tc>
+                <a:extLst>
+                  <a:ext uri="{0D108BD9-81ED-4DB2-BD59-A6C34878D82A}">
+                    <a16:rowId xmlns:a16="http://schemas.microsoft.com/office/drawing/2014/main" val="10002"/>
+                  </a:ext>
+                </a:extLst>
               </a:tr>
               <a:tr h="432261">
                 <a:tc>
@@ -7696,6 +8212,11 @@
                     </a:solidFill>
                   </a:tcPr>
                 </a:tc>
+                <a:extLst>
+                  <a:ext uri="{0D108BD9-81ED-4DB2-BD59-A6C34878D82A}">
+                    <a16:rowId xmlns:a16="http://schemas.microsoft.com/office/drawing/2014/main" val="10003"/>
+                  </a:ext>
+                </a:extLst>
               </a:tr>
               <a:tr h="432261">
                 <a:tc>
@@ -7790,6 +8311,11 @@
                     </a:solidFill>
                   </a:tcPr>
                 </a:tc>
+                <a:extLst>
+                  <a:ext uri="{0D108BD9-81ED-4DB2-BD59-A6C34878D82A}">
+                    <a16:rowId xmlns:a16="http://schemas.microsoft.com/office/drawing/2014/main" val="10004"/>
+                  </a:ext>
+                </a:extLst>
               </a:tr>
               <a:tr h="432261">
                 <a:tc>
@@ -7884,6 +8410,11 @@
                     </a:solidFill>
                   </a:tcPr>
                 </a:tc>
+                <a:extLst>
+                  <a:ext uri="{0D108BD9-81ED-4DB2-BD59-A6C34878D82A}">
+                    <a16:rowId xmlns:a16="http://schemas.microsoft.com/office/drawing/2014/main" val="10005"/>
+                  </a:ext>
+                </a:extLst>
               </a:tr>
               <a:tr h="432261">
                 <a:tc>
@@ -7978,6 +8509,11 @@
                     </a:solidFill>
                   </a:tcPr>
                 </a:tc>
+                <a:extLst>
+                  <a:ext uri="{0D108BD9-81ED-4DB2-BD59-A6C34878D82A}">
+                    <a16:rowId xmlns:a16="http://schemas.microsoft.com/office/drawing/2014/main" val="10006"/>
+                  </a:ext>
+                </a:extLst>
               </a:tr>
               <a:tr h="432261">
                 <a:tc>
@@ -8072,6 +8608,11 @@
                     </a:solidFill>
                   </a:tcPr>
                 </a:tc>
+                <a:extLst>
+                  <a:ext uri="{0D108BD9-81ED-4DB2-BD59-A6C34878D82A}">
+                    <a16:rowId xmlns:a16="http://schemas.microsoft.com/office/drawing/2014/main" val="10007"/>
+                  </a:ext>
+                </a:extLst>
               </a:tr>
               <a:tr h="432261">
                 <a:tc>
@@ -8166,6 +8707,11 @@
                     </a:solidFill>
                   </a:tcPr>
                 </a:tc>
+                <a:extLst>
+                  <a:ext uri="{0D108BD9-81ED-4DB2-BD59-A6C34878D82A}">
+                    <a16:rowId xmlns:a16="http://schemas.microsoft.com/office/drawing/2014/main" val="10008"/>
+                  </a:ext>
+                </a:extLst>
               </a:tr>
               <a:tr h="432261">
                 <a:tc>
@@ -8260,6 +8806,11 @@
                     </a:solidFill>
                   </a:tcPr>
                 </a:tc>
+                <a:extLst>
+                  <a:ext uri="{0D108BD9-81ED-4DB2-BD59-A6C34878D82A}">
+                    <a16:rowId xmlns:a16="http://schemas.microsoft.com/office/drawing/2014/main" val="10009"/>
+                  </a:ext>
+                </a:extLst>
               </a:tr>
               <a:tr h="432270">
                 <a:tc>
@@ -8354,6 +8905,11 @@
                     </a:solidFill>
                   </a:tcPr>
                 </a:tc>
+                <a:extLst>
+                  <a:ext uri="{0D108BD9-81ED-4DB2-BD59-A6C34878D82A}">
+                    <a16:rowId xmlns:a16="http://schemas.microsoft.com/office/drawing/2014/main" val="10010"/>
+                  </a:ext>
+                </a:extLst>
               </a:tr>
             </a:tbl>
           </a:graphicData>
@@ -8368,7 +8924,7 @@
 </file>
 
 <file path=ppt/slides/slide5.xml><?xml version="1.0" encoding="utf-8"?>
-<p:sld xmlns:a="http://schemas.openxmlformats.org/drawingml/2006/main" xmlns:p="http://schemas.openxmlformats.org/presentationml/2006/main" xmlns:r="http://schemas.openxmlformats.org/officeDocument/2006/relationships">
+<p:sld xmlns:a="http://schemas.openxmlformats.org/drawingml/2006/main" xmlns:r="http://schemas.openxmlformats.org/officeDocument/2006/relationships" xmlns:p="http://schemas.openxmlformats.org/presentationml/2006/main">
   <p:cSld>
     <p:spTree>
       <p:nvGrpSpPr>
@@ -8376,7 +8932,14 @@
         <p:cNvGrpSpPr/>
         <p:nvPr/>
       </p:nvGrpSpPr>
-      <p:grpSpPr/>
+      <p:grpSpPr>
+        <a:xfrm>
+          <a:off x="0" y="0"/>
+          <a:ext cx="0" cy="0"/>
+          <a:chOff x="0" y="0"/>
+          <a:chExt cx="0" cy="0"/>
+        </a:xfrm>
+      </p:grpSpPr>
       <p:sp>
         <p:nvSpPr>
           <p:cNvPr id="2" name="Rectangle 1"/>
@@ -8417,6 +8980,399 @@
           <a:lstStyle/>
           <a:p>
             <a:pPr algn="ctr"/>
+            <a:endParaRPr/>
+          </a:p>
+        </p:txBody>
+      </p:sp>
+      <p:sp>
+        <p:nvSpPr>
+          <p:cNvPr id="3" name="TextBox 2"/>
+          <p:cNvSpPr txBox="1"/>
+          <p:nvPr/>
+        </p:nvSpPr>
+        <p:spPr>
+          <a:xfrm>
+            <a:off x="457200" y="274320"/>
+            <a:ext cx="7231852" cy="615553"/>
+          </a:xfrm>
+          <a:prstGeom prst="rect">
+            <a:avLst/>
+          </a:prstGeom>
+          <a:noFill/>
+        </p:spPr>
+        <p:txBody>
+          <a:bodyPr wrap="none" lIns="0" tIns="0" rIns="0" bIns="0">
+            <a:spAutoFit/>
+          </a:bodyPr>
+          <a:lstStyle/>
+          <a:p>
+            <a:pPr algn="l"/>
+            <a:r>
+              <a:rPr sz="4000" b="0" dirty="0">
+                <a:solidFill>
+                  <a:srgbClr val="C2410C"/>
+                </a:solidFill>
+                <a:latin typeface="Calibri Light"/>
+              </a:rPr>
+              <a:t>Work Completed: Data Engineering</a:t>
+            </a:r>
+          </a:p>
+        </p:txBody>
+      </p:sp>
+      <p:sp>
+        <p:nvSpPr>
+          <p:cNvPr id="4" name="TextBox 3"/>
+          <p:cNvSpPr txBox="1"/>
+          <p:nvPr/>
+        </p:nvSpPr>
+        <p:spPr>
+          <a:xfrm>
+            <a:off x="457199" y="1249985"/>
+            <a:ext cx="11277295" cy="365760"/>
+          </a:xfrm>
+          <a:prstGeom prst="rect">
+            <a:avLst/>
+          </a:prstGeom>
+          <a:noFill/>
+        </p:spPr>
+        <p:txBody>
+          <a:bodyPr wrap="none" lIns="0" tIns="0" rIns="0" bIns="0">
+            <a:spAutoFit/>
+          </a:bodyPr>
+          <a:lstStyle/>
+          <a:p>
+            <a:pPr algn="l"/>
+            <a:r>
+              <a:rPr sz="2000" dirty="0">
+                <a:solidFill>
+                  <a:srgbClr val="64748B"/>
+                </a:solidFill>
+                <a:latin typeface="Calibri"/>
+              </a:rPr>
+              <a:t>564-dim feature matrix, 7 modality blocks, frozen v1.2.</a:t>
+            </a:r>
+          </a:p>
+        </p:txBody>
+      </p:sp>
+      <p:sp>
+        <p:nvSpPr>
+          <p:cNvPr id="5" name="TextBox 4"/>
+          <p:cNvSpPr txBox="1"/>
+          <p:nvPr/>
+        </p:nvSpPr>
+        <p:spPr>
+          <a:xfrm>
+            <a:off x="457200" y="6537960"/>
+            <a:ext cx="11277295" cy="228600"/>
+          </a:xfrm>
+          <a:prstGeom prst="rect">
+            <a:avLst/>
+          </a:prstGeom>
+          <a:noFill/>
+        </p:spPr>
+        <p:txBody>
+          <a:bodyPr wrap="none" lIns="0" rIns="0">
+            <a:spAutoFit/>
+          </a:bodyPr>
+          <a:lstStyle/>
+          <a:p>
+            <a:pPr algn="l"/>
+            <a:r>
+              <a:rPr sz="1000">
+                <a:solidFill>
+                  <a:srgbClr val="64748B"/>
+                </a:solidFill>
+                <a:latin typeface="Calibri"/>
+              </a:rPr>
+              <a:t>SENG 474  ·  CineEmbed  ·  Slide 5 / 14</a:t>
+            </a:r>
+          </a:p>
+        </p:txBody>
+      </p:sp>
+      <p:sp>
+        <p:nvSpPr>
+          <p:cNvPr id="6" name="Rounded Rectangle 5"/>
+          <p:cNvSpPr/>
+          <p:nvPr/>
+        </p:nvSpPr>
+        <p:spPr>
+          <a:xfrm>
+            <a:off x="457200" y="1935785"/>
+            <a:ext cx="1828800" cy="365760"/>
+          </a:xfrm>
+          <a:prstGeom prst="roundRect">
+            <a:avLst>
+              <a:gd name="adj" fmla="val 50000"/>
+            </a:avLst>
+          </a:prstGeom>
+          <a:solidFill>
+            <a:srgbClr val="15803D"/>
+          </a:solidFill>
+          <a:ln>
+            <a:noFill/>
+          </a:ln>
+        </p:spPr>
+        <p:style>
+          <a:lnRef idx="1">
+            <a:schemeClr val="accent1"/>
+          </a:lnRef>
+          <a:fillRef idx="3">
+            <a:schemeClr val="accent1"/>
+          </a:fillRef>
+          <a:effectRef idx="2">
+            <a:schemeClr val="accent1"/>
+          </a:effectRef>
+          <a:fontRef idx="minor">
+            <a:schemeClr val="lt1"/>
+          </a:fontRef>
+        </p:style>
+        <p:txBody>
+          <a:bodyPr tIns="0" bIns="0" rtlCol="0" anchor="ctr"/>
+          <a:lstStyle/>
+          <a:p>
+            <a:pPr algn="ctr"/>
+            <a:r>
+              <a:rPr sz="1100" b="1" dirty="0">
+                <a:solidFill>
+                  <a:srgbClr val="FFFFFF"/>
+                </a:solidFill>
+                <a:latin typeface="Calibri"/>
+              </a:rPr>
+              <a:t>COMPLETE</a:t>
+            </a:r>
+          </a:p>
+        </p:txBody>
+      </p:sp>
+      <p:sp>
+        <p:nvSpPr>
+          <p:cNvPr id="7" name="TextBox 6"/>
+          <p:cNvSpPr txBox="1"/>
+          <p:nvPr/>
+        </p:nvSpPr>
+        <p:spPr>
+          <a:xfrm>
+            <a:off x="204854" y="2743200"/>
+            <a:ext cx="5040244" cy="2446824"/>
+          </a:xfrm>
+          <a:prstGeom prst="rect">
+            <a:avLst/>
+          </a:prstGeom>
+          <a:noFill/>
+        </p:spPr>
+        <p:txBody>
+          <a:bodyPr wrap="square" lIns="0" tIns="0" rIns="0" bIns="0">
+            <a:spAutoFit/>
+          </a:bodyPr>
+          <a:lstStyle/>
+          <a:p>
+            <a:pPr algn="l">
+              <a:spcAft>
+                <a:spcPts val="600"/>
+              </a:spcAft>
+            </a:pPr>
+            <a:r>
+              <a:rPr sz="1800" dirty="0">
+                <a:solidFill>
+                  <a:srgbClr val="1E293B"/>
+                </a:solidFill>
+                <a:latin typeface="Calibri"/>
+              </a:rPr>
+              <a:t>•  Three sources merged: TMDB, awards records, Wikipedia director bios.</a:t>
+            </a:r>
+          </a:p>
+          <a:p>
+            <a:pPr algn="l">
+              <a:spcAft>
+                <a:spcPts val="600"/>
+              </a:spcAft>
+            </a:pPr>
+            <a:r>
+              <a:rPr sz="1800" dirty="0">
+                <a:solidFill>
+                  <a:srgbClr val="1E293B"/>
+                </a:solidFill>
+                <a:latin typeface="Calibri"/>
+              </a:rPr>
+              <a:t>•  Sparse modalities preserved as one-hot (interpretable).</a:t>
+            </a:r>
+          </a:p>
+          <a:p>
+            <a:pPr algn="l">
+              <a:spcAft>
+                <a:spcPts val="600"/>
+              </a:spcAft>
+            </a:pPr>
+            <a:r>
+              <a:rPr sz="1800" dirty="0">
+                <a:solidFill>
+                  <a:srgbClr val="1E293B"/>
+                </a:solidFill>
+                <a:latin typeface="Calibri"/>
+              </a:rPr>
+              <a:t>•  Missing release date encoded as binary flag — turned out to be structurally relevant (slide 12).</a:t>
+            </a:r>
+          </a:p>
+          <a:p>
+            <a:pPr algn="l">
+              <a:spcAft>
+                <a:spcPts val="600"/>
+              </a:spcAft>
+            </a:pPr>
+            <a:r>
+              <a:rPr sz="1800" dirty="0">
+                <a:solidFill>
+                  <a:srgbClr val="1E293B"/>
+                </a:solidFill>
+                <a:latin typeface="Calibri"/>
+              </a:rPr>
+              <a:t>•  Director-bio reconstruction loss masked by </a:t>
+            </a:r>
+            <a:r>
+              <a:rPr sz="1800" dirty="0" err="1">
+                <a:solidFill>
+                  <a:srgbClr val="1E293B"/>
+                </a:solidFill>
+                <a:latin typeface="Calibri"/>
+              </a:rPr>
+              <a:t>has_director_bio</a:t>
+            </a:r>
+            <a:r>
+              <a:rPr sz="1800" dirty="0">
+                <a:solidFill>
+                  <a:srgbClr val="1E293B"/>
+                </a:solidFill>
+                <a:latin typeface="Calibri"/>
+              </a:rPr>
+              <a:t> flag (G2 masking).</a:t>
+            </a:r>
+          </a:p>
+        </p:txBody>
+      </p:sp>
+      <p:pic>
+        <p:nvPicPr>
+          <p:cNvPr id="8" name="Picture 7" descr="multilingual_coverage.png"/>
+          <p:cNvPicPr>
+            <a:picLocks noChangeAspect="1"/>
+          </p:cNvPicPr>
+          <p:nvPr/>
+        </p:nvPicPr>
+        <p:blipFill>
+          <a:blip r:embed="rId2"/>
+          <a:stretch>
+            <a:fillRect/>
+          </a:stretch>
+        </p:blipFill>
+        <p:spPr>
+          <a:xfrm>
+            <a:off x="5245098" y="2263103"/>
+            <a:ext cx="6946902" cy="2708114"/>
+          </a:xfrm>
+          <a:prstGeom prst="rect">
+            <a:avLst/>
+          </a:prstGeom>
+        </p:spPr>
+      </p:pic>
+      <p:sp>
+        <p:nvSpPr>
+          <p:cNvPr id="9" name="TextBox 8"/>
+          <p:cNvSpPr txBox="1"/>
+          <p:nvPr/>
+        </p:nvSpPr>
+        <p:spPr>
+          <a:xfrm>
+            <a:off x="7040880" y="5852160"/>
+            <a:ext cx="4754880" cy="365760"/>
+          </a:xfrm>
+          <a:prstGeom prst="rect">
+            <a:avLst/>
+          </a:prstGeom>
+          <a:noFill/>
+        </p:spPr>
+        <p:txBody>
+          <a:bodyPr wrap="none">
+            <a:spAutoFit/>
+          </a:bodyPr>
+          <a:lstStyle/>
+          <a:p>
+            <a:pPr algn="ctr"/>
+            <a:r>
+              <a:rPr sz="1200" i="1">
+                <a:solidFill>
+                  <a:srgbClr val="64748B"/>
+                </a:solidFill>
+                <a:latin typeface="Calibri"/>
+              </a:rPr>
+              <a:t>Multilingual coverage — long tail motivates sparsity-aware design.</a:t>
+            </a:r>
+          </a:p>
+        </p:txBody>
+      </p:sp>
+    </p:spTree>
+  </p:cSld>
+  <p:clrMapOvr>
+    <a:masterClrMapping/>
+  </p:clrMapOvr>
+</p:sld>
+</file>
+
+<file path=ppt/slides/slide6.xml><?xml version="1.0" encoding="utf-8"?>
+<p:sld xmlns:a="http://schemas.openxmlformats.org/drawingml/2006/main" xmlns:r="http://schemas.openxmlformats.org/officeDocument/2006/relationships" xmlns:p="http://schemas.openxmlformats.org/presentationml/2006/main">
+  <p:cSld>
+    <p:spTree>
+      <p:nvGrpSpPr>
+        <p:cNvPr id="1" name=""/>
+        <p:cNvGrpSpPr/>
+        <p:nvPr/>
+      </p:nvGrpSpPr>
+      <p:grpSpPr>
+        <a:xfrm>
+          <a:off x="0" y="0"/>
+          <a:ext cx="0" cy="0"/>
+          <a:chOff x="0" y="0"/>
+          <a:chExt cx="0" cy="0"/>
+        </a:xfrm>
+      </p:grpSpPr>
+      <p:sp>
+        <p:nvSpPr>
+          <p:cNvPr id="2" name="Rectangle 1"/>
+          <p:cNvSpPr/>
+          <p:nvPr/>
+        </p:nvSpPr>
+        <p:spPr>
+          <a:xfrm>
+            <a:off x="0" y="0"/>
+            <a:ext cx="12191695" cy="75895"/>
+          </a:xfrm>
+          <a:prstGeom prst="rect">
+            <a:avLst/>
+          </a:prstGeom>
+          <a:solidFill>
+            <a:srgbClr val="C2410C"/>
+          </a:solidFill>
+          <a:ln>
+            <a:noFill/>
+          </a:ln>
+        </p:spPr>
+        <p:style>
+          <a:lnRef idx="1">
+            <a:schemeClr val="accent1"/>
+          </a:lnRef>
+          <a:fillRef idx="3">
+            <a:schemeClr val="accent1"/>
+          </a:fillRef>
+          <a:effectRef idx="2">
+            <a:schemeClr val="accent1"/>
+          </a:effectRef>
+          <a:fontRef idx="minor">
+            <a:schemeClr val="lt1"/>
+          </a:fontRef>
+        </p:style>
+        <p:txBody>
+          <a:bodyPr rtlCol="0" anchor="ctr"/>
+          <a:lstStyle/>
+          <a:p>
+            <a:pPr algn="ctr"/>
+            <a:endParaRPr/>
           </a:p>
         </p:txBody>
       </p:sp>
@@ -8437,7 +9393,7 @@
           <a:noFill/>
         </p:spPr>
         <p:txBody>
-          <a:bodyPr wrap="none" lIns="0" rIns="0" tIns="0" bIns="0">
+          <a:bodyPr wrap="none" lIns="0" tIns="0" rIns="0" bIns="0">
             <a:spAutoFit/>
           </a:bodyPr>
           <a:lstStyle/>
@@ -8450,7 +9406,7 @@
                 </a:solidFill>
                 <a:latin typeface="Calibri Light"/>
               </a:rPr>
-              <a:t>Work Completed: Data Engineering</a:t>
+              <a:t>Work Completed: Architecture Design</a:t>
             </a:r>
           </a:p>
         </p:txBody>
@@ -8472,7 +9428,7 @@
           <a:noFill/>
         </p:spPr>
         <p:txBody>
-          <a:bodyPr wrap="none" lIns="0" rIns="0" tIns="0" bIns="0">
+          <a:bodyPr wrap="none" lIns="0" tIns="0" rIns="0" bIns="0">
             <a:spAutoFit/>
           </a:bodyPr>
           <a:lstStyle/>
@@ -8485,7 +9441,7 @@
                 </a:solidFill>
                 <a:latin typeface="Calibri"/>
               </a:rPr>
-              <a:t>564-dim feature matrix, 7 modality blocks, frozen v1.2.</a:t>
+              <a:t>Multi-modal backbone, W2 inverse-variance loss, G2 bio masking, DEC head.</a:t>
             </a:r>
           </a:p>
         </p:txBody>
@@ -8520,7 +9476,7 @@
                 </a:solidFill>
                 <a:latin typeface="Calibri"/>
               </a:rPr>
-              <a:t>SENG 474  ·  CineEmbed  ·  Slide 5 / 14</a:t>
+              <a:t>SENG 474  ·  CineEmbed  ·  Slide 6 / 14</a:t>
             </a:r>
           </a:p>
         </p:txBody>
@@ -8563,7 +9519,7 @@
           </a:fontRef>
         </p:style>
         <p:txBody>
-          <a:bodyPr rtlCol="0" anchor="ctr" tIns="0" bIns="0"/>
+          <a:bodyPr tIns="0" bIns="0" rtlCol="0" anchor="ctr"/>
           <a:lstStyle/>
           <a:p>
             <a:pPr algn="ctr"/>
@@ -8579,96 +9535,9 @@
           </a:p>
         </p:txBody>
       </p:sp>
-      <p:sp>
-        <p:nvSpPr>
-          <p:cNvPr id="7" name="TextBox 6"/>
-          <p:cNvSpPr txBox="1"/>
-          <p:nvPr/>
-        </p:nvSpPr>
-        <p:spPr>
-          <a:xfrm>
-            <a:off x="457200" y="2057400"/>
-            <a:ext cx="6400800" cy="4114800"/>
-          </a:xfrm>
-          <a:prstGeom prst="rect">
-            <a:avLst/>
-          </a:prstGeom>
-          <a:noFill/>
-        </p:spPr>
-        <p:txBody>
-          <a:bodyPr wrap="square" lIns="0" rIns="0" tIns="0" bIns="0">
-            <a:spAutoFit/>
-          </a:bodyPr>
-          <a:lstStyle/>
-          <a:p>
-            <a:pPr algn="l">
-              <a:spcAft>
-                <a:spcPts val="600"/>
-              </a:spcAft>
-            </a:pPr>
-            <a:r>
-              <a:rPr sz="1800">
-                <a:solidFill>
-                  <a:srgbClr val="1E293B"/>
-                </a:solidFill>
-                <a:latin typeface="Calibri"/>
-              </a:rPr>
-              <a:t>•  Three sources merged: TMDB, awards records, Wikipedia director bios.</a:t>
-            </a:r>
-          </a:p>
-          <a:p>
-            <a:pPr algn="l">
-              <a:spcAft>
-                <a:spcPts val="600"/>
-              </a:spcAft>
-            </a:pPr>
-            <a:r>
-              <a:rPr sz="1800">
-                <a:solidFill>
-                  <a:srgbClr val="1E293B"/>
-                </a:solidFill>
-                <a:latin typeface="Calibri"/>
-              </a:rPr>
-              <a:t>•  Sparse modalities preserved as one-hot (interpretable).</a:t>
-            </a:r>
-          </a:p>
-          <a:p>
-            <a:pPr algn="l">
-              <a:spcAft>
-                <a:spcPts val="600"/>
-              </a:spcAft>
-            </a:pPr>
-            <a:r>
-              <a:rPr sz="1800">
-                <a:solidFill>
-                  <a:srgbClr val="1E293B"/>
-                </a:solidFill>
-                <a:latin typeface="Calibri"/>
-              </a:rPr>
-              <a:t>•  Missing release date encoded as binary flag — turned out to be structurally relevant (slide 12).</a:t>
-            </a:r>
-          </a:p>
-          <a:p>
-            <a:pPr algn="l">
-              <a:spcAft>
-                <a:spcPts val="600"/>
-              </a:spcAft>
-            </a:pPr>
-            <a:r>
-              <a:rPr sz="1800">
-                <a:solidFill>
-                  <a:srgbClr val="1E293B"/>
-                </a:solidFill>
-                <a:latin typeface="Calibri"/>
-              </a:rPr>
-              <a:t>•  Director-bio reconstruction loss masked by has_director_bio flag (G2 masking).</a:t>
-            </a:r>
-          </a:p>
-        </p:txBody>
-      </p:sp>
       <p:pic>
         <p:nvPicPr>
-          <p:cNvPr id="8" name="Picture 7" descr="multilingual_coverage.png"/>
+          <p:cNvPr id="7" name="Picture 6" descr="architecture_multimodal.png"/>
           <p:cNvPicPr>
             <a:picLocks noChangeAspect="1"/>
           </p:cNvPicPr>
@@ -8682,49 +9551,14 @@
         </p:blipFill>
         <p:spPr>
           <a:xfrm>
-            <a:off x="7040880" y="1874519"/>
-            <a:ext cx="4754880" cy="1853597"/>
+            <a:off x="612435" y="1986920"/>
+            <a:ext cx="10594281" cy="4540407"/>
           </a:xfrm>
           <a:prstGeom prst="rect">
             <a:avLst/>
           </a:prstGeom>
         </p:spPr>
       </p:pic>
-      <p:sp>
-        <p:nvSpPr>
-          <p:cNvPr id="9" name="TextBox 8"/>
-          <p:cNvSpPr txBox="1"/>
-          <p:nvPr/>
-        </p:nvSpPr>
-        <p:spPr>
-          <a:xfrm>
-            <a:off x="7040880" y="5852160"/>
-            <a:ext cx="4754880" cy="365760"/>
-          </a:xfrm>
-          <a:prstGeom prst="rect">
-            <a:avLst/>
-          </a:prstGeom>
-          <a:noFill/>
-        </p:spPr>
-        <p:txBody>
-          <a:bodyPr wrap="none">
-            <a:spAutoFit/>
-          </a:bodyPr>
-          <a:lstStyle/>
-          <a:p>
-            <a:pPr algn="ctr"/>
-            <a:r>
-              <a:rPr sz="1200" i="1">
-                <a:solidFill>
-                  <a:srgbClr val="64748B"/>
-                </a:solidFill>
-                <a:latin typeface="Calibri"/>
-              </a:rPr>
-              <a:t>Multilingual coverage — long tail motivates sparsity-aware design.</a:t>
-            </a:r>
-          </a:p>
-        </p:txBody>
-      </p:sp>
     </p:spTree>
   </p:cSld>
   <p:clrMapOvr>
@@ -8733,8 +9567,8 @@
 </p:sld>
 </file>
 
-<file path=ppt/slides/slide6.xml><?xml version="1.0" encoding="utf-8"?>
-<p:sld xmlns:a="http://schemas.openxmlformats.org/drawingml/2006/main" xmlns:p="http://schemas.openxmlformats.org/presentationml/2006/main" xmlns:r="http://schemas.openxmlformats.org/officeDocument/2006/relationships">
+<file path=ppt/slides/slide7.xml><?xml version="1.0" encoding="utf-8"?>
+<p:sld xmlns:a="http://schemas.openxmlformats.org/drawingml/2006/main" xmlns:r="http://schemas.openxmlformats.org/officeDocument/2006/relationships" xmlns:p="http://schemas.openxmlformats.org/presentationml/2006/main">
   <p:cSld>
     <p:spTree>
       <p:nvGrpSpPr>
@@ -8742,7 +9576,14 @@
         <p:cNvGrpSpPr/>
         <p:nvPr/>
       </p:nvGrpSpPr>
-      <p:grpSpPr/>
+      <p:grpSpPr>
+        <a:xfrm>
+          <a:off x="0" y="0"/>
+          <a:ext cx="0" cy="0"/>
+          <a:chOff x="0" y="0"/>
+          <a:chExt cx="0" cy="0"/>
+        </a:xfrm>
+      </p:grpSpPr>
       <p:sp>
         <p:nvSpPr>
           <p:cNvPr id="2" name="Rectangle 1"/>
@@ -8783,6 +9624,7 @@
           <a:lstStyle/>
           <a:p>
             <a:pPr algn="ctr"/>
+            <a:endParaRPr/>
           </a:p>
         </p:txBody>
       </p:sp>
@@ -8803,7 +9645,7 @@
           <a:noFill/>
         </p:spPr>
         <p:txBody>
-          <a:bodyPr wrap="none" lIns="0" rIns="0" tIns="0" bIns="0">
+          <a:bodyPr wrap="none" lIns="0" tIns="0" rIns="0" bIns="0">
             <a:spAutoFit/>
           </a:bodyPr>
           <a:lstStyle/>
@@ -8816,7 +9658,7 @@
                 </a:solidFill>
                 <a:latin typeface="Calibri Light"/>
               </a:rPr>
-              <a:t>Work Completed: Architecture Design</a:t>
+              <a:t>Metrics — How We Measure Cluster Quality</a:t>
             </a:r>
           </a:p>
         </p:txBody>
@@ -8838,338 +9680,7 @@
           <a:noFill/>
         </p:spPr>
         <p:txBody>
-          <a:bodyPr wrap="none" lIns="0" rIns="0" tIns="0" bIns="0">
-            <a:spAutoFit/>
-          </a:bodyPr>
-          <a:lstStyle/>
-          <a:p>
-            <a:pPr algn="l"/>
-            <a:r>
-              <a:rPr sz="2000">
-                <a:solidFill>
-                  <a:srgbClr val="64748B"/>
-                </a:solidFill>
-                <a:latin typeface="Calibri"/>
-              </a:rPr>
-              <a:t>Multi-modal backbone, W2 inverse-variance loss, G2 bio masking, DEC head.</a:t>
-            </a:r>
-          </a:p>
-        </p:txBody>
-      </p:sp>
-      <p:sp>
-        <p:nvSpPr>
-          <p:cNvPr id="5" name="TextBox 4"/>
-          <p:cNvSpPr txBox="1"/>
-          <p:nvPr/>
-        </p:nvSpPr>
-        <p:spPr>
-          <a:xfrm>
-            <a:off x="457200" y="6537960"/>
-            <a:ext cx="11277295" cy="228600"/>
-          </a:xfrm>
-          <a:prstGeom prst="rect">
-            <a:avLst/>
-          </a:prstGeom>
-          <a:noFill/>
-        </p:spPr>
-        <p:txBody>
-          <a:bodyPr wrap="none" lIns="0" rIns="0">
-            <a:spAutoFit/>
-          </a:bodyPr>
-          <a:lstStyle/>
-          <a:p>
-            <a:pPr algn="l"/>
-            <a:r>
-              <a:rPr sz="1000">
-                <a:solidFill>
-                  <a:srgbClr val="64748B"/>
-                </a:solidFill>
-                <a:latin typeface="Calibri"/>
-              </a:rPr>
-              <a:t>SENG 474  ·  CineEmbed  ·  Slide 6 / 14</a:t>
-            </a:r>
-          </a:p>
-        </p:txBody>
-      </p:sp>
-      <p:sp>
-        <p:nvSpPr>
-          <p:cNvPr id="6" name="Rounded Rectangle 5"/>
-          <p:cNvSpPr/>
-          <p:nvPr/>
-        </p:nvSpPr>
-        <p:spPr>
-          <a:xfrm>
-            <a:off x="457200" y="1417320"/>
-            <a:ext cx="1828800" cy="365760"/>
-          </a:xfrm>
-          <a:prstGeom prst="roundRect">
-            <a:avLst>
-              <a:gd name="adj" fmla="val 50000"/>
-            </a:avLst>
-          </a:prstGeom>
-          <a:solidFill>
-            <a:srgbClr val="15803D"/>
-          </a:solidFill>
-          <a:ln>
-            <a:noFill/>
-          </a:ln>
-        </p:spPr>
-        <p:style>
-          <a:lnRef idx="1">
-            <a:schemeClr val="accent1"/>
-          </a:lnRef>
-          <a:fillRef idx="3">
-            <a:schemeClr val="accent1"/>
-          </a:fillRef>
-          <a:effectRef idx="2">
-            <a:schemeClr val="accent1"/>
-          </a:effectRef>
-          <a:fontRef idx="minor">
-            <a:schemeClr val="lt1"/>
-          </a:fontRef>
-        </p:style>
-        <p:txBody>
-          <a:bodyPr rtlCol="0" anchor="ctr" tIns="0" bIns="0"/>
-          <a:lstStyle/>
-          <a:p>
-            <a:pPr algn="ctr"/>
-            <a:r>
-              <a:rPr sz="1100" b="1">
-                <a:solidFill>
-                  <a:srgbClr val="FFFFFF"/>
-                </a:solidFill>
-                <a:latin typeface="Calibri"/>
-              </a:rPr>
-              <a:t>COMPLETE</a:t>
-            </a:r>
-          </a:p>
-        </p:txBody>
-      </p:sp>
-      <p:pic>
-        <p:nvPicPr>
-          <p:cNvPr id="7" name="Picture 6" descr="architecture_multimodal.png"/>
-          <p:cNvPicPr>
-            <a:picLocks noChangeAspect="1"/>
-          </p:cNvPicPr>
-          <p:nvPr/>
-        </p:nvPicPr>
-        <p:blipFill>
-          <a:blip r:embed="rId2"/>
-          <a:stretch>
-            <a:fillRect/>
-          </a:stretch>
-        </p:blipFill>
-        <p:spPr>
-          <a:xfrm>
-            <a:off x="548640" y="1920240"/>
-            <a:ext cx="7772400" cy="3331029"/>
-          </a:xfrm>
-          <a:prstGeom prst="rect">
-            <a:avLst/>
-          </a:prstGeom>
-        </p:spPr>
-      </p:pic>
-      <p:sp>
-        <p:nvSpPr>
-          <p:cNvPr id="8" name="TextBox 7"/>
-          <p:cNvSpPr txBox="1"/>
-          <p:nvPr/>
-        </p:nvSpPr>
-        <p:spPr>
-          <a:xfrm>
-            <a:off x="8595360" y="2057400"/>
-            <a:ext cx="3200400" cy="4114800"/>
-          </a:xfrm>
-          <a:prstGeom prst="rect">
-            <a:avLst/>
-          </a:prstGeom>
-          <a:noFill/>
-        </p:spPr>
-        <p:txBody>
-          <a:bodyPr wrap="square" lIns="0" rIns="0" tIns="0" bIns="0">
-            <a:spAutoFit/>
-          </a:bodyPr>
-          <a:lstStyle/>
-          <a:p>
-            <a:pPr algn="l">
-              <a:spcAft>
-                <a:spcPts val="600"/>
-              </a:spcAft>
-            </a:pPr>
-            <a:r>
-              <a:rPr sz="1500">
-                <a:solidFill>
-                  <a:srgbClr val="1E293B"/>
-                </a:solidFill>
-                <a:latin typeface="Calibri"/>
-              </a:rPr>
-              <a:t>•  7 modality projections → concat (164-dim) → backbone → z=64.</a:t>
-            </a:r>
-          </a:p>
-          <a:p>
-            <a:pPr algn="l">
-              <a:spcAft>
-                <a:spcPts val="600"/>
-              </a:spcAft>
-            </a:pPr>
-            <a:r>
-              <a:rPr sz="1500">
-                <a:solidFill>
-                  <a:srgbClr val="1E293B"/>
-                </a:solidFill>
-                <a:latin typeface="Calibri"/>
-              </a:rPr>
-              <a:t>•  W2: per-block inverse-variance weighting (clipped to [0.1, 10]).</a:t>
-            </a:r>
-          </a:p>
-          <a:p>
-            <a:pPr algn="l">
-              <a:spcAft>
-                <a:spcPts val="600"/>
-              </a:spcAft>
-            </a:pPr>
-            <a:r>
-              <a:rPr sz="1500">
-                <a:solidFill>
-                  <a:srgbClr val="1E293B"/>
-                </a:solidFill>
-                <a:latin typeface="Calibri"/>
-              </a:rPr>
-              <a:t>•  G2: mask bio reconstruction loss by has_director_bio.</a:t>
-            </a:r>
-          </a:p>
-          <a:p>
-            <a:pPr algn="l">
-              <a:spcAft>
-                <a:spcPts val="600"/>
-              </a:spcAft>
-            </a:pPr>
-            <a:r>
-              <a:rPr sz="1500">
-                <a:solidFill>
-                  <a:srgbClr val="1E293B"/>
-                </a:solidFill>
-                <a:latin typeface="Calibri"/>
-              </a:rPr>
-              <a:t>•  DEC head: Student-t soft assignment, k=21, γ=0.1 on KL.</a:t>
-            </a:r>
-          </a:p>
-        </p:txBody>
-      </p:sp>
-    </p:spTree>
-  </p:cSld>
-  <p:clrMapOvr>
-    <a:masterClrMapping/>
-  </p:clrMapOvr>
-</p:sld>
-</file>
-
-<file path=ppt/slides/slide7.xml><?xml version="1.0" encoding="utf-8"?>
-<p:sld xmlns:a="http://schemas.openxmlformats.org/drawingml/2006/main" xmlns:p="http://schemas.openxmlformats.org/presentationml/2006/main" xmlns:r="http://schemas.openxmlformats.org/officeDocument/2006/relationships">
-  <p:cSld>
-    <p:spTree>
-      <p:nvGrpSpPr>
-        <p:cNvPr id="1" name=""/>
-        <p:cNvGrpSpPr/>
-        <p:nvPr/>
-      </p:nvGrpSpPr>
-      <p:grpSpPr/>
-      <p:sp>
-        <p:nvSpPr>
-          <p:cNvPr id="2" name="Rectangle 1"/>
-          <p:cNvSpPr/>
-          <p:nvPr/>
-        </p:nvSpPr>
-        <p:spPr>
-          <a:xfrm>
-            <a:off x="0" y="0"/>
-            <a:ext cx="12191695" cy="75895"/>
-          </a:xfrm>
-          <a:prstGeom prst="rect">
-            <a:avLst/>
-          </a:prstGeom>
-          <a:solidFill>
-            <a:srgbClr val="C2410C"/>
-          </a:solidFill>
-          <a:ln>
-            <a:noFill/>
-          </a:ln>
-        </p:spPr>
-        <p:style>
-          <a:lnRef idx="1">
-            <a:schemeClr val="accent1"/>
-          </a:lnRef>
-          <a:fillRef idx="3">
-            <a:schemeClr val="accent1"/>
-          </a:fillRef>
-          <a:effectRef idx="2">
-            <a:schemeClr val="accent1"/>
-          </a:effectRef>
-          <a:fontRef idx="minor">
-            <a:schemeClr val="lt1"/>
-          </a:fontRef>
-        </p:style>
-        <p:txBody>
-          <a:bodyPr rtlCol="0" anchor="ctr"/>
-          <a:lstStyle/>
-          <a:p>
-            <a:pPr algn="ctr"/>
-          </a:p>
-        </p:txBody>
-      </p:sp>
-      <p:sp>
-        <p:nvSpPr>
-          <p:cNvPr id="3" name="TextBox 2"/>
-          <p:cNvSpPr txBox="1"/>
-          <p:nvPr/>
-        </p:nvSpPr>
-        <p:spPr>
-          <a:xfrm>
-            <a:off x="457200" y="274320"/>
-            <a:ext cx="11277295" cy="685800"/>
-          </a:xfrm>
-          <a:prstGeom prst="rect">
-            <a:avLst/>
-          </a:prstGeom>
-          <a:noFill/>
-        </p:spPr>
-        <p:txBody>
-          <a:bodyPr wrap="none" lIns="0" rIns="0" tIns="0" bIns="0">
-            <a:spAutoFit/>
-          </a:bodyPr>
-          <a:lstStyle/>
-          <a:p>
-            <a:pPr algn="l"/>
-            <a:r>
-              <a:rPr sz="3600" b="0">
-                <a:solidFill>
-                  <a:srgbClr val="C2410C"/>
-                </a:solidFill>
-                <a:latin typeface="Calibri Light"/>
-              </a:rPr>
-              <a:t>Metrics — How We Measure Cluster Quality</a:t>
-            </a:r>
-          </a:p>
-        </p:txBody>
-      </p:sp>
-      <p:sp>
-        <p:nvSpPr>
-          <p:cNvPr id="4" name="TextBox 3"/>
-          <p:cNvSpPr txBox="1"/>
-          <p:nvPr/>
-        </p:nvSpPr>
-        <p:spPr>
-          <a:xfrm>
-            <a:off x="457200" y="914400"/>
-            <a:ext cx="11277295" cy="365760"/>
-          </a:xfrm>
-          <a:prstGeom prst="rect">
-            <a:avLst/>
-          </a:prstGeom>
-          <a:noFill/>
-        </p:spPr>
-        <p:txBody>
-          <a:bodyPr wrap="none" lIns="0" rIns="0" tIns="0" bIns="0">
+          <a:bodyPr wrap="none" lIns="0" tIns="0" rIns="0" bIns="0">
             <a:spAutoFit/>
           </a:bodyPr>
           <a:lstStyle/>
@@ -9266,6 +9777,7 @@
           <a:lstStyle/>
           <a:p>
             <a:pPr algn="ctr"/>
+            <a:endParaRPr/>
           </a:p>
         </p:txBody>
       </p:sp>
@@ -9286,7 +9798,7 @@
           <a:noFill/>
         </p:spPr>
         <p:txBody>
-          <a:bodyPr wrap="square" lIns="0" rIns="0" tIns="0" bIns="0">
+          <a:bodyPr wrap="square" lIns="0" tIns="0" rIns="0" bIns="0">
             <a:spAutoFit/>
           </a:bodyPr>
           <a:lstStyle/>
@@ -9468,6 +9980,7 @@
           <a:lstStyle/>
           <a:p>
             <a:pPr algn="ctr"/>
+            <a:endParaRPr/>
           </a:p>
         </p:txBody>
       </p:sp>
@@ -9488,7 +10001,7 @@
           <a:noFill/>
         </p:spPr>
         <p:txBody>
-          <a:bodyPr wrap="square" lIns="0" rIns="0" tIns="0" bIns="0">
+          <a:bodyPr wrap="square" lIns="0" tIns="0" rIns="0" bIns="0">
             <a:spAutoFit/>
           </a:bodyPr>
           <a:lstStyle/>
@@ -9645,11 +10158,41 @@
                 <a:tableStyleId>{5C22544A-7EE6-4342-B048-85BDC9FD1C3A}</a:tableStyleId>
               </a:tblPr>
               <a:tblGrid>
-                <a:gridCol w="2255459"/>
-                <a:gridCol w="2255459"/>
-                <a:gridCol w="2255459"/>
-                <a:gridCol w="2255459"/>
-                <a:gridCol w="2255459"/>
+                <a:gridCol w="2255459">
+                  <a:extLst>
+                    <a:ext uri="{9D8B030D-6E8A-4147-A177-3AD203B41FA5}">
+                      <a16:colId xmlns:a16="http://schemas.microsoft.com/office/drawing/2014/main" val="20000"/>
+                    </a:ext>
+                  </a:extLst>
+                </a:gridCol>
+                <a:gridCol w="2255459">
+                  <a:extLst>
+                    <a:ext uri="{9D8B030D-6E8A-4147-A177-3AD203B41FA5}">
+                      <a16:colId xmlns:a16="http://schemas.microsoft.com/office/drawing/2014/main" val="20001"/>
+                    </a:ext>
+                  </a:extLst>
+                </a:gridCol>
+                <a:gridCol w="2255459">
+                  <a:extLst>
+                    <a:ext uri="{9D8B030D-6E8A-4147-A177-3AD203B41FA5}">
+                      <a16:colId xmlns:a16="http://schemas.microsoft.com/office/drawing/2014/main" val="20002"/>
+                    </a:ext>
+                  </a:extLst>
+                </a:gridCol>
+                <a:gridCol w="2255459">
+                  <a:extLst>
+                    <a:ext uri="{9D8B030D-6E8A-4147-A177-3AD203B41FA5}">
+                      <a16:colId xmlns:a16="http://schemas.microsoft.com/office/drawing/2014/main" val="20003"/>
+                    </a:ext>
+                  </a:extLst>
+                </a:gridCol>
+                <a:gridCol w="2255459">
+                  <a:extLst>
+                    <a:ext uri="{9D8B030D-6E8A-4147-A177-3AD203B41FA5}">
+                      <a16:colId xmlns:a16="http://schemas.microsoft.com/office/drawing/2014/main" val="20004"/>
+                    </a:ext>
+                  </a:extLst>
+                </a:gridCol>
               </a:tblGrid>
               <a:tr h="354330">
                 <a:tc>
@@ -9767,6 +10310,11 @@
                     </a:solidFill>
                   </a:tcPr>
                 </a:tc>
+                <a:extLst>
+                  <a:ext uri="{0D108BD9-81ED-4DB2-BD59-A6C34878D82A}">
+                    <a16:rowId xmlns:a16="http://schemas.microsoft.com/office/drawing/2014/main" val="10000"/>
+                  </a:ext>
+                </a:extLst>
               </a:tr>
               <a:tr h="354330">
                 <a:tc>
@@ -9884,6 +10432,11 @@
                     </a:solidFill>
                   </a:tcPr>
                 </a:tc>
+                <a:extLst>
+                  <a:ext uri="{0D108BD9-81ED-4DB2-BD59-A6C34878D82A}">
+                    <a16:rowId xmlns:a16="http://schemas.microsoft.com/office/drawing/2014/main" val="10001"/>
+                  </a:ext>
+                </a:extLst>
               </a:tr>
               <a:tr h="354330">
                 <a:tc>
@@ -10001,6 +10554,11 @@
                     </a:solidFill>
                   </a:tcPr>
                 </a:tc>
+                <a:extLst>
+                  <a:ext uri="{0D108BD9-81ED-4DB2-BD59-A6C34878D82A}">
+                    <a16:rowId xmlns:a16="http://schemas.microsoft.com/office/drawing/2014/main" val="10002"/>
+                  </a:ext>
+                </a:extLst>
               </a:tr>
               <a:tr h="354330">
                 <a:tc>
@@ -10118,6 +10676,11 @@
                     </a:solidFill>
                   </a:tcPr>
                 </a:tc>
+                <a:extLst>
+                  <a:ext uri="{0D108BD9-81ED-4DB2-BD59-A6C34878D82A}">
+                    <a16:rowId xmlns:a16="http://schemas.microsoft.com/office/drawing/2014/main" val="10003"/>
+                  </a:ext>
+                </a:extLst>
               </a:tr>
             </a:tbl>
           </a:graphicData>
@@ -10163,6 +10726,7 @@
           <a:lstStyle/>
           <a:p>
             <a:pPr algn="ctr"/>
+            <a:endParaRPr/>
           </a:p>
         </p:txBody>
       </p:sp>
@@ -10183,7 +10747,7 @@
           <a:noFill/>
         </p:spPr>
         <p:txBody>
-          <a:bodyPr wrap="square" lIns="0" rIns="0" tIns="0" bIns="0">
+          <a:bodyPr wrap="square" lIns="0" tIns="0" rIns="0" bIns="0">
             <a:spAutoFit/>
           </a:bodyPr>
           <a:lstStyle/>
@@ -10219,7 +10783,7 @@
 </file>
 
 <file path=ppt/slides/slide8.xml><?xml version="1.0" encoding="utf-8"?>
-<p:sld xmlns:a="http://schemas.openxmlformats.org/drawingml/2006/main" xmlns:p="http://schemas.openxmlformats.org/presentationml/2006/main" xmlns:r="http://schemas.openxmlformats.org/officeDocument/2006/relationships">
+<p:sld xmlns:a="http://schemas.openxmlformats.org/drawingml/2006/main" xmlns:r="http://schemas.openxmlformats.org/officeDocument/2006/relationships" xmlns:p="http://schemas.openxmlformats.org/presentationml/2006/main">
   <p:cSld>
     <p:spTree>
       <p:nvGrpSpPr>
@@ -10227,7 +10791,14 @@
         <p:cNvGrpSpPr/>
         <p:nvPr/>
       </p:nvGrpSpPr>
-      <p:grpSpPr/>
+      <p:grpSpPr>
+        <a:xfrm>
+          <a:off x="0" y="0"/>
+          <a:ext cx="0" cy="0"/>
+          <a:chOff x="0" y="0"/>
+          <a:chExt cx="0" cy="0"/>
+        </a:xfrm>
+      </p:grpSpPr>
       <p:sp>
         <p:nvSpPr>
           <p:cNvPr id="2" name="Rectangle 1"/>
@@ -10268,6 +10839,7 @@
           <a:lstStyle/>
           <a:p>
             <a:pPr algn="ctr"/>
+            <a:endParaRPr/>
           </a:p>
         </p:txBody>
       </p:sp>
@@ -10288,7 +10860,7 @@
           <a:noFill/>
         </p:spPr>
         <p:txBody>
-          <a:bodyPr wrap="none" lIns="0" rIns="0" tIns="0" bIns="0">
+          <a:bodyPr wrap="none" lIns="0" tIns="0" rIns="0" bIns="0">
             <a:spAutoFit/>
           </a:bodyPr>
           <a:lstStyle/>
@@ -10323,7 +10895,7 @@
           <a:noFill/>
         </p:spPr>
         <p:txBody>
-          <a:bodyPr wrap="none" lIns="0" rIns="0" tIns="0" bIns="0">
+          <a:bodyPr wrap="none" lIns="0" tIns="0" rIns="0" bIns="0">
             <a:spAutoFit/>
           </a:bodyPr>
           <a:lstStyle/>
@@ -10414,7 +10986,7 @@
           </a:fontRef>
         </p:style>
         <p:txBody>
-          <a:bodyPr rtlCol="0" anchor="ctr" tIns="0" bIns="0"/>
+          <a:bodyPr tIns="0" bIns="0" rtlCol="0" anchor="ctr"/>
           <a:lstStyle/>
           <a:p>
             <a:pPr algn="ctr"/>
@@ -10449,13 +11021,55 @@
                 <a:tableStyleId>{5C22544A-7EE6-4342-B048-85BDC9FD1C3A}</a:tableStyleId>
               </a:tblPr>
               <a:tblGrid>
-                <a:gridCol w="1611042"/>
-                <a:gridCol w="1611042"/>
-                <a:gridCol w="1611042"/>
-                <a:gridCol w="1611042"/>
-                <a:gridCol w="1611042"/>
-                <a:gridCol w="1611042"/>
-                <a:gridCol w="1611043"/>
+                <a:gridCol w="1611042">
+                  <a:extLst>
+                    <a:ext uri="{9D8B030D-6E8A-4147-A177-3AD203B41FA5}">
+                      <a16:colId xmlns:a16="http://schemas.microsoft.com/office/drawing/2014/main" val="20000"/>
+                    </a:ext>
+                  </a:extLst>
+                </a:gridCol>
+                <a:gridCol w="1611042">
+                  <a:extLst>
+                    <a:ext uri="{9D8B030D-6E8A-4147-A177-3AD203B41FA5}">
+                      <a16:colId xmlns:a16="http://schemas.microsoft.com/office/drawing/2014/main" val="20001"/>
+                    </a:ext>
+                  </a:extLst>
+                </a:gridCol>
+                <a:gridCol w="1611042">
+                  <a:extLst>
+                    <a:ext uri="{9D8B030D-6E8A-4147-A177-3AD203B41FA5}">
+                      <a16:colId xmlns:a16="http://schemas.microsoft.com/office/drawing/2014/main" val="20002"/>
+                    </a:ext>
+                  </a:extLst>
+                </a:gridCol>
+                <a:gridCol w="1611042">
+                  <a:extLst>
+                    <a:ext uri="{9D8B030D-6E8A-4147-A177-3AD203B41FA5}">
+                      <a16:colId xmlns:a16="http://schemas.microsoft.com/office/drawing/2014/main" val="20003"/>
+                    </a:ext>
+                  </a:extLst>
+                </a:gridCol>
+                <a:gridCol w="1611042">
+                  <a:extLst>
+                    <a:ext uri="{9D8B030D-6E8A-4147-A177-3AD203B41FA5}">
+                      <a16:colId xmlns:a16="http://schemas.microsoft.com/office/drawing/2014/main" val="20004"/>
+                    </a:ext>
+                  </a:extLst>
+                </a:gridCol>
+                <a:gridCol w="1611042">
+                  <a:extLst>
+                    <a:ext uri="{9D8B030D-6E8A-4147-A177-3AD203B41FA5}">
+                      <a16:colId xmlns:a16="http://schemas.microsoft.com/office/drawing/2014/main" val="20005"/>
+                    </a:ext>
+                  </a:extLst>
+                </a:gridCol>
+                <a:gridCol w="1611043">
+                  <a:extLst>
+                    <a:ext uri="{9D8B030D-6E8A-4147-A177-3AD203B41FA5}">
+                      <a16:colId xmlns:a16="http://schemas.microsoft.com/office/drawing/2014/main" val="20006"/>
+                    </a:ext>
+                  </a:extLst>
+                </a:gridCol>
               </a:tblGrid>
               <a:tr h="522514">
                 <a:tc>
@@ -10619,6 +11233,11 @@
                     </a:solidFill>
                   </a:tcPr>
                 </a:tc>
+                <a:extLst>
+                  <a:ext uri="{0D108BD9-81ED-4DB2-BD59-A6C34878D82A}">
+                    <a16:rowId xmlns:a16="http://schemas.microsoft.com/office/drawing/2014/main" val="10000"/>
+                  </a:ext>
+                </a:extLst>
               </a:tr>
               <a:tr h="522514">
                 <a:tc>
@@ -10782,6 +11401,11 @@
                     </a:solidFill>
                   </a:tcPr>
                 </a:tc>
+                <a:extLst>
+                  <a:ext uri="{0D108BD9-81ED-4DB2-BD59-A6C34878D82A}">
+                    <a16:rowId xmlns:a16="http://schemas.microsoft.com/office/drawing/2014/main" val="10001"/>
+                  </a:ext>
+                </a:extLst>
               </a:tr>
               <a:tr h="522514">
                 <a:tc>
@@ -10945,6 +11569,11 @@
                     </a:solidFill>
                   </a:tcPr>
                 </a:tc>
+                <a:extLst>
+                  <a:ext uri="{0D108BD9-81ED-4DB2-BD59-A6C34878D82A}">
+                    <a16:rowId xmlns:a16="http://schemas.microsoft.com/office/drawing/2014/main" val="10002"/>
+                  </a:ext>
+                </a:extLst>
               </a:tr>
               <a:tr h="522514">
                 <a:tc>
@@ -11108,6 +11737,11 @@
                     </a:solidFill>
                   </a:tcPr>
                 </a:tc>
+                <a:extLst>
+                  <a:ext uri="{0D108BD9-81ED-4DB2-BD59-A6C34878D82A}">
+                    <a16:rowId xmlns:a16="http://schemas.microsoft.com/office/drawing/2014/main" val="10003"/>
+                  </a:ext>
+                </a:extLst>
               </a:tr>
               <a:tr h="522514">
                 <a:tc>
@@ -11271,6 +11905,11 @@
                     </a:solidFill>
                   </a:tcPr>
                 </a:tc>
+                <a:extLst>
+                  <a:ext uri="{0D108BD9-81ED-4DB2-BD59-A6C34878D82A}">
+                    <a16:rowId xmlns:a16="http://schemas.microsoft.com/office/drawing/2014/main" val="10004"/>
+                  </a:ext>
+                </a:extLst>
               </a:tr>
               <a:tr h="522514">
                 <a:tc>
@@ -11434,6 +12073,11 @@
                     </a:solidFill>
                   </a:tcPr>
                 </a:tc>
+                <a:extLst>
+                  <a:ext uri="{0D108BD9-81ED-4DB2-BD59-A6C34878D82A}">
+                    <a16:rowId xmlns:a16="http://schemas.microsoft.com/office/drawing/2014/main" val="10005"/>
+                  </a:ext>
+                </a:extLst>
               </a:tr>
               <a:tr h="522516">
                 <a:tc>
@@ -11597,6 +12241,11 @@
                     </a:solidFill>
                   </a:tcPr>
                 </a:tc>
+                <a:extLst>
+                  <a:ext uri="{0D108BD9-81ED-4DB2-BD59-A6C34878D82A}">
+                    <a16:rowId xmlns:a16="http://schemas.microsoft.com/office/drawing/2014/main" val="10006"/>
+                  </a:ext>
+                </a:extLst>
               </a:tr>
             </a:tbl>
           </a:graphicData>
@@ -11645,7 +12294,7 @@
 </file>
 
 <file path=ppt/slides/slide9.xml><?xml version="1.0" encoding="utf-8"?>
-<p:sld xmlns:a="http://schemas.openxmlformats.org/drawingml/2006/main" xmlns:p="http://schemas.openxmlformats.org/presentationml/2006/main" xmlns:r="http://schemas.openxmlformats.org/officeDocument/2006/relationships">
+<p:sld xmlns:a="http://schemas.openxmlformats.org/drawingml/2006/main" xmlns:r="http://schemas.openxmlformats.org/officeDocument/2006/relationships" xmlns:p="http://schemas.openxmlformats.org/presentationml/2006/main">
   <p:cSld>
     <p:spTree>
       <p:nvGrpSpPr>
@@ -11653,7 +12302,14 @@
         <p:cNvGrpSpPr/>
         <p:nvPr/>
       </p:nvGrpSpPr>
-      <p:grpSpPr/>
+      <p:grpSpPr>
+        <a:xfrm>
+          <a:off x="0" y="0"/>
+          <a:ext cx="0" cy="0"/>
+          <a:chOff x="0" y="0"/>
+          <a:chExt cx="0" cy="0"/>
+        </a:xfrm>
+      </p:grpSpPr>
       <p:sp>
         <p:nvSpPr>
           <p:cNvPr id="2" name="Rectangle 1"/>
@@ -11694,6 +12350,7 @@
           <a:lstStyle/>
           <a:p>
             <a:pPr algn="ctr"/>
+            <a:endParaRPr/>
           </a:p>
         </p:txBody>
       </p:sp>
@@ -11714,7 +12371,7 @@
           <a:noFill/>
         </p:spPr>
         <p:txBody>
-          <a:bodyPr wrap="none" lIns="0" rIns="0" tIns="0" bIns="0">
+          <a:bodyPr wrap="none" lIns="0" tIns="0" rIns="0" bIns="0">
             <a:spAutoFit/>
           </a:bodyPr>
           <a:lstStyle/>
@@ -11749,7 +12406,7 @@
           <a:noFill/>
         </p:spPr>
         <p:txBody>
-          <a:bodyPr wrap="none" lIns="0" rIns="0" tIns="0" bIns="0">
+          <a:bodyPr wrap="none" lIns="0" tIns="0" rIns="0" bIns="0">
             <a:spAutoFit/>
           </a:bodyPr>
           <a:lstStyle/>
@@ -11840,7 +12497,7 @@
           </a:fontRef>
         </p:style>
         <p:txBody>
-          <a:bodyPr rtlCol="0" anchor="ctr" tIns="0" bIns="0"/>
+          <a:bodyPr tIns="0" bIns="0" rtlCol="0" anchor="ctr"/>
           <a:lstStyle/>
           <a:p>
             <a:pPr algn="ctr"/>
@@ -11875,10 +12532,34 @@
                 <a:tableStyleId>{5C22544A-7EE6-4342-B048-85BDC9FD1C3A}</a:tableStyleId>
               </a:tblPr>
               <a:tblGrid>
-                <a:gridCol w="2819323"/>
-                <a:gridCol w="2819323"/>
-                <a:gridCol w="2819323"/>
-                <a:gridCol w="2819326"/>
+                <a:gridCol w="2819323">
+                  <a:extLst>
+                    <a:ext uri="{9D8B030D-6E8A-4147-A177-3AD203B41FA5}">
+                      <a16:colId xmlns:a16="http://schemas.microsoft.com/office/drawing/2014/main" val="20000"/>
+                    </a:ext>
+                  </a:extLst>
+                </a:gridCol>
+                <a:gridCol w="2819323">
+                  <a:extLst>
+                    <a:ext uri="{9D8B030D-6E8A-4147-A177-3AD203B41FA5}">
+                      <a16:colId xmlns:a16="http://schemas.microsoft.com/office/drawing/2014/main" val="20001"/>
+                    </a:ext>
+                  </a:extLst>
+                </a:gridCol>
+                <a:gridCol w="2819323">
+                  <a:extLst>
+                    <a:ext uri="{9D8B030D-6E8A-4147-A177-3AD203B41FA5}">
+                      <a16:colId xmlns:a16="http://schemas.microsoft.com/office/drawing/2014/main" val="20002"/>
+                    </a:ext>
+                  </a:extLst>
+                </a:gridCol>
+                <a:gridCol w="2819326">
+                  <a:extLst>
+                    <a:ext uri="{9D8B030D-6E8A-4147-A177-3AD203B41FA5}">
+                      <a16:colId xmlns:a16="http://schemas.microsoft.com/office/drawing/2014/main" val="20003"/>
+                    </a:ext>
+                  </a:extLst>
+                </a:gridCol>
               </a:tblGrid>
               <a:tr h="582930">
                 <a:tc>
@@ -11973,6 +12654,11 @@
                     </a:solidFill>
                   </a:tcPr>
                 </a:tc>
+                <a:extLst>
+                  <a:ext uri="{0D108BD9-81ED-4DB2-BD59-A6C34878D82A}">
+                    <a16:rowId xmlns:a16="http://schemas.microsoft.com/office/drawing/2014/main" val="10000"/>
+                  </a:ext>
+                </a:extLst>
               </a:tr>
               <a:tr h="582930">
                 <a:tc>
@@ -12067,6 +12753,11 @@
                     </a:solidFill>
                   </a:tcPr>
                 </a:tc>
+                <a:extLst>
+                  <a:ext uri="{0D108BD9-81ED-4DB2-BD59-A6C34878D82A}">
+                    <a16:rowId xmlns:a16="http://schemas.microsoft.com/office/drawing/2014/main" val="10001"/>
+                  </a:ext>
+                </a:extLst>
               </a:tr>
               <a:tr h="582930">
                 <a:tc>
@@ -12161,6 +12852,11 @@
                     </a:solidFill>
                   </a:tcPr>
                 </a:tc>
+                <a:extLst>
+                  <a:ext uri="{0D108BD9-81ED-4DB2-BD59-A6C34878D82A}">
+                    <a16:rowId xmlns:a16="http://schemas.microsoft.com/office/drawing/2014/main" val="10002"/>
+                  </a:ext>
+                </a:extLst>
               </a:tr>
               <a:tr h="582930">
                 <a:tc>
@@ -12255,6 +12951,11 @@
                     </a:solidFill>
                   </a:tcPr>
                 </a:tc>
+                <a:extLst>
+                  <a:ext uri="{0D108BD9-81ED-4DB2-BD59-A6C34878D82A}">
+                    <a16:rowId xmlns:a16="http://schemas.microsoft.com/office/drawing/2014/main" val="10003"/>
+                  </a:ext>
+                </a:extLst>
               </a:tr>
             </a:tbl>
           </a:graphicData>
@@ -12300,6 +13001,7 @@
           <a:lstStyle/>
           <a:p>
             <a:pPr algn="ctr"/>
+            <a:endParaRPr/>
           </a:p>
         </p:txBody>
       </p:sp>

</xml_diff>